<commit_message>
feat: add collision risk vulnerability composite figure and ignore documentation artifacts in gitignore
</commit_message>
<xml_diff>
--- a/Progress_Presentation.pptx
+++ b/Progress_Presentation.pptx
@@ -17,6 +17,7 @@
     <p:sldId id="265" r:id="rId11"/>
     <p:sldId id="266" r:id="rId12"/>
     <p:sldId id="267" r:id="rId13"/>
+    <p:sldId id="272" r:id="rId23"/>
     <p:sldId id="271" r:id="rId22"/>
     <p:sldId id="268" r:id="rId14"/>
     <p:sldId id="269" r:id="rId15"/>
@@ -5161,12 +5162,16 @@
             </a:lvl1pPr>
           </a:lstStyle>
           <a:p>
-            <a:pPr algn="l"/>
-            <a:fld id="{F7021451-1387-4CA6-816F-3879F97B5CBC}" type="slidenum">
-              <a:rPr b="0" lang="en-US"/>
+            <a:pPr>
+              <a:defRPr sz="1000">
+                <a:solidFill>
+                  <a:srgbClr val="94A3B8"/>
+                </a:solidFill>
+              </a:defRPr>
+            </a:pPr>
+            <a:r>
               <a:t>10</a:t>
-            </a:fld>
-            <a:endParaRPr lang="en-US"/>
+            </a:r>
           </a:p>
         </p:txBody>
       </p:sp>
@@ -5471,15 +5476,39 @@
               <a:buNone/>
             </a:pPr>
             <a:r>
-              <a:rPr sz="1080">
-                <a:solidFill>
-                  <a:srgbClr val="5D6B7E"/>
+              <a:rPr sz="950" b="0">
+                <a:solidFill>
+                  <a:srgbClr val="334155"/>
                 </a:solidFill>
                 <a:latin typeface="Arial"/>
               </a:rPr>
-              <a:t>Step size Δt = 0.1s (10 Hz), RSU sort period = 2.0s (0.5 Hz), consensus gains kp = 0.15, kv = 0.80, jerk limit = 2.5 m/s³, radar lookahead = 150m, TTC threshold = 2.0s.</a:t>
+              <a:t>• Step size Δt = 0.1 s (10 Hz) | RSU sort period = 2.0 s (0.5 Hz)</a:t>
             </a:r>
             <a:endParaRPr lang="en-US" sz="1080" dirty="0"/>
+          </a:p>
+          <a:p>
+            <a:pPr algn="l"/>
+            <a:r>
+              <a:rPr sz="950" b="0">
+                <a:solidFill>
+                  <a:srgbClr val="334155"/>
+                </a:solidFill>
+                <a:latin typeface="Arial"/>
+              </a:rPr>
+              <a:t>• Consensus gains: kp = 0.15, kv = 0.80 | Jerk limit = 2.5 m/s³</a:t>
+            </a:r>
+          </a:p>
+          <a:p>
+            <a:pPr algn="l"/>
+            <a:r>
+              <a:rPr sz="950" b="0">
+                <a:solidFill>
+                  <a:srgbClr val="334155"/>
+                </a:solidFill>
+                <a:latin typeface="Arial"/>
+              </a:rPr>
+              <a:t>• Radar lookahead = 150 m | Safety TTC threshold = 2.0 s</a:t>
+            </a:r>
           </a:p>
         </p:txBody>
       </p:sp>
@@ -5609,15 +5638,39 @@
               <a:buNone/>
             </a:pPr>
             <a:r>
-              <a:rPr sz="1080">
-                <a:solidFill>
-                  <a:srgbClr val="5D6B7E"/>
+              <a:rPr sz="950" b="0">
+                <a:solidFill>
+                  <a:srgbClr val="334155"/>
                 </a:solidFill>
                 <a:latin typeface="Arial"/>
               </a:rPr>
-              <a:t>300.0s multi-vehicle simulation; reproducible RNG channel seeds; full 0.1s telemetry tracking position, velocity, acceleration, command, predecessor age, and wireless packet transfers.</a:t>
+              <a:t>• 300.0 s horizon with 75 total CAVs (50 highway, 25 ramp)</a:t>
             </a:r>
             <a:endParaRPr lang="en-US" sz="1080" dirty="0"/>
+          </a:p>
+          <a:p>
+            <a:pPr algn="l"/>
+            <a:r>
+              <a:rPr sz="950" b="0">
+                <a:solidFill>
+                  <a:srgbClr val="334155"/>
+                </a:solidFill>
+                <a:latin typeface="Arial"/>
+              </a:rPr>
+              <a:t>• Full 0.1 s telemetry: speed, acceleration, gap, predecessor age</a:t>
+            </a:r>
+          </a:p>
+          <a:p>
+            <a:pPr algn="l"/>
+            <a:r>
+              <a:rPr sz="950" b="0">
+                <a:solidFill>
+                  <a:srgbClr val="334155"/>
+                </a:solidFill>
+                <a:latin typeface="Arial"/>
+              </a:rPr>
+              <a:t>• Reproducible RNG seeds for channel noise &amp; packet loss models</a:t>
+            </a:r>
           </a:p>
         </p:txBody>
       </p:sp>
@@ -5747,15 +5800,39 @@
               <a:buNone/>
             </a:pPr>
             <a:r>
-              <a:rPr sz="1080">
-                <a:solidFill>
-                  <a:srgbClr val="5D6B7E"/>
+              <a:rPr sz="950" b="0">
+                <a:solidFill>
+                  <a:srgbClr val="334155"/>
                 </a:solidFill>
                 <a:latin typeface="Arial"/>
               </a:rPr>
-              <a:t>1) Perfect Comm (10 Hz periodic V2V baseline); 2) Event-Triggered V2V (Proposed); 3) Real Comm with 0% loss; 4) Real Comm with 10% packet drop; 5) Real Comm with 30% packet drop.</a:t>
+              <a:t>• 1) Perfect Comm (10 Hz periodic V2V baseline)</a:t>
             </a:r>
             <a:endParaRPr lang="en-US" sz="1080" dirty="0"/>
+          </a:p>
+          <a:p>
+            <a:pPr algn="l"/>
+            <a:r>
+              <a:rPr sz="950" b="0">
+                <a:solidFill>
+                  <a:srgbClr val="1565C0"/>
+                </a:solidFill>
+                <a:latin typeface="Arial"/>
+              </a:rPr>
+              <a:t>• 2) Event-Triggered V2V (Proposed framework)</a:t>
+            </a:r>
+          </a:p>
+          <a:p>
+            <a:pPr algn="l"/>
+            <a:r>
+              <a:rPr sz="950" b="0">
+                <a:solidFill>
+                  <a:srgbClr val="334155"/>
+                </a:solidFill>
+                <a:latin typeface="Arial"/>
+              </a:rPr>
+              <a:t>• 3) Real Comm (0% loss) | 4) 10% loss | 5) 30% loss</a:t>
+            </a:r>
           </a:p>
         </p:txBody>
       </p:sp>
@@ -5885,15 +5962,39 @@
               <a:buNone/>
             </a:pPr>
             <a:r>
-              <a:rPr sz="1080">
-                <a:solidFill>
-                  <a:srgbClr val="5D6B7E"/>
+              <a:rPr sz="950" b="0">
+                <a:solidFill>
+                  <a:srgbClr val="334155"/>
                 </a:solidFill>
                 <a:latin typeface="Arial"/>
               </a:rPr>
-              <a:t>Safety (collisions, TTC &lt; 2.0s conflicts), Communication Cost (packet counts, total data volume KB, bitrate kbps), and Traffic Stability (merge speed, speed variance).</a:t>
+              <a:t>• Safety: Physical collisions, emergency TTC conflict events (&lt;2.0 s)</a:t>
             </a:r>
             <a:endParaRPr lang="en-US" sz="1080" dirty="0"/>
+          </a:p>
+          <a:p>
+            <a:pPr algn="l"/>
+            <a:r>
+              <a:rPr sz="950" b="0">
+                <a:solidFill>
+                  <a:srgbClr val="334155"/>
+                </a:solidFill>
+                <a:latin typeface="Arial"/>
+              </a:rPr>
+              <a:t>• Communication: V2V packet volume, data volume (KB), bitrate (kbps)</a:t>
+            </a:r>
+          </a:p>
+          <a:p>
+            <a:pPr algn="l"/>
+            <a:r>
+              <a:rPr sz="950" b="0">
+                <a:solidFill>
+                  <a:srgbClr val="334155"/>
+                </a:solidFill>
+                <a:latin typeface="Arial"/>
+              </a:rPr>
+              <a:t>• Traffic Flow: Merge velocity convergence, speed variance, stability</a:t>
+            </a:r>
           </a:p>
         </p:txBody>
       </p:sp>
@@ -6045,12 +6146,16 @@
             </a:lvl1pPr>
           </a:lstStyle>
           <a:p>
-            <a:pPr algn="l"/>
-            <a:fld id="{F7021451-1387-4CA6-816F-3879F97B5CBC}" type="slidenum">
-              <a:rPr b="0" lang="en-US"/>
+            <a:pPr>
+              <a:defRPr sz="1000">
+                <a:solidFill>
+                  <a:srgbClr val="94A3B8"/>
+                </a:solidFill>
+              </a:defRPr>
+            </a:pPr>
+            <a:r>
               <a:t>11</a:t>
-            </a:fld>
-            <a:endParaRPr lang="en-US"/>
+            </a:r>
           </a:p>
         </p:txBody>
       </p:sp>
@@ -6923,47 +7028,53 @@
               <a:buNone/>
             </a:pPr>
             <a:r>
-              <a:rPr sz="1080">
-                <a:solidFill>
-                  <a:srgbClr val="D7E4EE"/>
+              <a:rPr sz="1100" b="1">
+                <a:solidFill>
+                  <a:srgbClr val="0F172A"/>
                 </a:solidFill>
                 <a:latin typeface="Arial"/>
               </a:rPr>
-              <a:t>What improved, and by how much?</a:t>
+              <a:t>Communication Overhead Reduction</a:t>
             </a:r>
             <a:endParaRPr lang="en-US" sz="1080" dirty="0"/>
           </a:p>
-          <a:p>
-            <a:r>
-              <a:rPr sz="1080">
-                <a:solidFill>
-                  <a:srgbClr val="D7E4EE"/>
+          <a:p/>
+          <a:p/>
+          <a:p/>
+          <a:p>
+            <a:pPr algn="l"/>
+            <a:r>
+              <a:rPr sz="950" b="0">
+                <a:solidFill>
+                  <a:srgbClr val="334155"/>
                 </a:solidFill>
                 <a:latin typeface="Arial"/>
               </a:rPr>
-              <a:t>• V2V transmissions dropped by 89.60% (from 16,129 to 1,677 packets).</a:t>
-            </a:r>
-          </a:p>
-          <a:p>
-            <a:r>
-              <a:rPr sz="1080">
-                <a:solidFill>
-                  <a:srgbClr val="D7E4EE"/>
+              <a:t>• V2V transmissions plummeted by 89.60% (16,129 down to 1,677 packets).</a:t>
+            </a:r>
+          </a:p>
+          <a:p>
+            <a:pPr algn="l"/>
+            <a:r>
+              <a:rPr sz="950" b="0">
+                <a:solidFill>
+                  <a:srgbClr val="334155"/>
                 </a:solidFill>
                 <a:latin typeface="Arial"/>
               </a:rPr>
-              <a:t>• Total wireless data reduced by 78.73% (from 1,147.2 KB to 243.9 KB).</a:t>
-            </a:r>
-          </a:p>
-          <a:p>
-            <a:r>
-              <a:rPr sz="1080">
-                <a:solidFill>
-                  <a:srgbClr val="D7E4EE"/>
+              <a:t>• Bandwidth volume dropped by 78.73% (1,147 KB down to 244 KB).</a:t>
+            </a:r>
+          </a:p>
+          <a:p>
+            <a:pPr algn="l"/>
+            <a:r>
+              <a:rPr sz="950" b="0">
+                <a:solidFill>
+                  <a:srgbClr val="334155"/>
                 </a:solidFill>
                 <a:latin typeface="Arial"/>
               </a:rPr>
-              <a:t>• Average bitrate dropped from 31.33 kbps to 6.66 kbps with zero collisions.</a:t>
+              <a:t>• Transmission bitrate reduced from 31.3 kbps to 6.66 kbps.</a:t>
             </a:r>
           </a:p>
         </p:txBody>
@@ -7024,47 +7135,53 @@
               <a:buNone/>
             </a:pPr>
             <a:r>
-              <a:rPr sz="1080">
-                <a:solidFill>
-                  <a:srgbClr val="D7E4EE"/>
+              <a:rPr sz="1100" b="1">
+                <a:solidFill>
+                  <a:srgbClr val="0F172A"/>
                 </a:solidFill>
                 <a:latin typeface="Arial"/>
               </a:rPr>
-              <a:t>How does the system handle packet loss?</a:t>
+              <a:t>Channel Loss Resilience (10% &amp; 30%)</a:t>
             </a:r>
             <a:endParaRPr lang="en-US" sz="1080" dirty="0"/>
           </a:p>
-          <a:p>
-            <a:r>
-              <a:rPr sz="1080">
-                <a:solidFill>
-                  <a:srgbClr val="D7E4EE"/>
+          <a:p/>
+          <a:p/>
+          <a:p/>
+          <a:p>
+            <a:pPr algn="l"/>
+            <a:r>
+              <a:rPr sz="950" b="0">
+                <a:solidFill>
+                  <a:srgbClr val="334155"/>
                 </a:solidFill>
                 <a:latin typeface="Arial"/>
               </a:rPr>
-              <a:t>• Under 10% and 30% packet loss, linear dead reckoning prevented false braking.</a:t>
-            </a:r>
-          </a:p>
-          <a:p>
-            <a:r>
-              <a:rPr sz="1080">
-                <a:solidFill>
-                  <a:srgbClr val="D7E4EE"/>
+              <a:t>• Constant-velocity dead reckoning bridged packet gaps up to 4.3 s.</a:t>
+            </a:r>
+          </a:p>
+          <a:p>
+            <a:pPr algn="l"/>
+            <a:r>
+              <a:rPr sz="950" b="0">
+                <a:solidFill>
+                  <a:srgbClr val="334155"/>
                 </a:solidFill>
                 <a:latin typeface="Arial"/>
               </a:rPr>
-              <a:t>• Max predecessor age reached 4.3s during deep loss bursts with zero collisions.</a:t>
-            </a:r>
-          </a:p>
-          <a:p>
-            <a:r>
-              <a:rPr sz="1080">
-                <a:solidFill>
-                  <a:srgbClr val="D7E4EE"/>
+              <a:t>• Prevented false emergency braking or accordion shockwaves.</a:t>
+            </a:r>
+          </a:p>
+          <a:p>
+            <a:pPr algn="l"/>
+            <a:r>
+              <a:rPr sz="950" b="0">
+                <a:solidFill>
+                  <a:srgbClr val="334155"/>
                 </a:solidFill>
                 <a:latin typeface="Arial"/>
               </a:rPr>
-              <a:t>• Radar fail-safe stood ready as autonomous safety net but required 0 emergency overrides.</a:t>
+              <a:t>• Radar fail-safe stood ready but required 0 interventions.</a:t>
             </a:r>
           </a:p>
         </p:txBody>
@@ -7125,36 +7242,40 @@
               <a:buNone/>
             </a:pPr>
             <a:r>
-              <a:rPr sz="1080">
-                <a:solidFill>
-                  <a:srgbClr val="D7E4EE"/>
+              <a:rPr sz="1100" b="1">
+                <a:solidFill>
+                  <a:srgbClr val="0F172A"/>
                 </a:solidFill>
                 <a:latin typeface="Arial"/>
               </a:rPr>
-              <a:t>Which result supports the core hypothesis?</a:t>
+              <a:t>Core Research Hypothesis Validated</a:t>
             </a:r>
             <a:endParaRPr lang="en-US" sz="1080" dirty="0"/>
           </a:p>
-          <a:p>
-            <a:r>
-              <a:rPr sz="1080">
-                <a:solidFill>
-                  <a:srgbClr val="D7E4EE"/>
+          <a:p/>
+          <a:p/>
+          <a:p>
+            <a:pPr algn="l"/>
+            <a:r>
+              <a:rPr sz="950" b="0">
+                <a:solidFill>
+                  <a:srgbClr val="1565C0"/>
                 </a:solidFill>
                 <a:latin typeface="Arial"/>
               </a:rPr>
-              <a:t>• The observed collision-free merges with zero TTC fail-safe interventions support the hypothesis that high-rate periodic broadcasting is not always necessary for longitudinal safety.</a:t>
-            </a:r>
-          </a:p>
-          <a:p>
-            <a:r>
-              <a:rPr sz="1080">
-                <a:solidFill>
-                  <a:srgbClr val="D7E4EE"/>
+              <a:t>• Continuous 10 Hz beaconing is NOT required for longitudinal safety.</a:t>
+            </a:r>
+          </a:p>
+          <a:p>
+            <a:pPr algn="l"/>
+            <a:r>
+              <a:rPr sz="950" b="0">
+                <a:solidFill>
+                  <a:srgbClr val="334155"/>
                 </a:solidFill>
                 <a:latin typeface="Arial"/>
               </a:rPr>
-              <a:t>• State updates are only needed during acceleration, deceleration, or drift.</a:t>
+              <a:t>• Event triggers communicate strictly when kinematic shifts occur.</a:t>
             </a:r>
           </a:p>
         </p:txBody>
@@ -7215,36 +7336,40 @@
               <a:buNone/>
             </a:pPr>
             <a:r>
-              <a:rPr sz="1080">
-                <a:solidFill>
-                  <a:srgbClr val="D7E4EE"/>
+              <a:rPr sz="1100" b="1">
+                <a:solidFill>
+                  <a:srgbClr val="0F172A"/>
                 </a:solidFill>
                 <a:latin typeface="Arial"/>
               </a:rPr>
-              <a:t>Current boundaries and next steps</a:t>
+              <a:t>Current Boundaries &amp; Scope</a:t>
             </a:r>
             <a:endParaRPr lang="en-US" sz="1080" dirty="0"/>
           </a:p>
-          <a:p>
-            <a:r>
-              <a:rPr sz="1080">
-                <a:solidFill>
-                  <a:srgbClr val="D7E4EE"/>
+          <a:p/>
+          <a:p/>
+          <a:p>
+            <a:pPr algn="l"/>
+            <a:r>
+              <a:rPr sz="950" b="0">
+                <a:solidFill>
+                  <a:srgbClr val="334155"/>
                 </a:solidFill>
                 <a:latin typeface="Arial"/>
               </a:rPr>
-              <a:t>• Present evaluation validates single-lane bottleneck geometries.</a:t>
-            </a:r>
-          </a:p>
-          <a:p>
-            <a:r>
-              <a:rPr sz="1080">
-                <a:solidFill>
-                  <a:srgbClr val="D7E4EE"/>
+              <a:t>• Single-lane merge geometry with 100% CAV penetration validated.</a:t>
+            </a:r>
+          </a:p>
+          <a:p>
+            <a:pPr algn="l"/>
+            <a:r>
+              <a:rPr sz="950" b="0">
+                <a:solidFill>
+                  <a:srgbClr val="64748B"/>
                 </a:solidFill>
                 <a:latin typeface="Arial"/>
               </a:rPr>
-              <a:t>• Multi-lane highway weaving and unequipped human vehicles will be addressed in W1–W3.</a:t>
+              <a:t>• Multi-lane highway weaving and mixed human traffic targeted in W1–W3.</a:t>
             </a:r>
           </a:p>
         </p:txBody>
@@ -7288,12 +7413,16 @@
             </a:lvl1pPr>
           </a:lstStyle>
           <a:p>
-            <a:pPr algn="l"/>
-            <a:fld id="{F7021451-1387-4CA6-816F-3879F97B5CBC}" type="slidenum">
-              <a:rPr b="0" lang="en-US"/>
+            <a:pPr>
+              <a:defRPr sz="1000">
+                <a:solidFill>
+                  <a:srgbClr val="94A3B8"/>
+                </a:solidFill>
+              </a:defRPr>
+            </a:pPr>
+            <a:r>
               <a:t>12</a:t>
-            </a:fld>
-            <a:endParaRPr lang="en-US"/>
+            </a:r>
           </a:p>
         </p:txBody>
       </p:sp>
@@ -7340,31 +7469,31 @@
             <a:pPr>
               <a:defRPr sz="1100" b="1">
                 <a:solidFill>
-                  <a:srgbClr val="1565C0"/>
+                  <a:srgbClr val="DC2626"/>
                 </a:solidFill>
               </a:defRPr>
             </a:pPr>
             <a:r>
-              <a:t>12 • VISUAL EVIDENCE : SIMULATION DASHBOARDS &amp; TRAJECTORIES</a:t>
+              <a:t>12 • VULNERABILITY ANALYSIS: COLLISION RISK WITHOUT FAIL-SAFE</a:t>
             </a:r>
           </a:p>
           <a:p>
             <a:pPr>
-              <a:defRPr sz="1800" b="1">
-                <a:solidFill>
-                  <a:srgbClr val="212121"/>
+              <a:defRPr sz="1700" b="1">
+                <a:solidFill>
+                  <a:srgbClr val="0F172A"/>
                 </a:solidFill>
               </a:defRPr>
             </a:pPr>
             <a:r>
-              <a:t>Microscopic Trajectory Convergence &amp; Empirical Communication Benchmarks</a:t>
+              <a:t>Empirical Failure Modes: Realistic Wireless Impairments Induce Severe Collisions Without Fail-Safe Control</a:t>
             </a:r>
           </a:p>
         </p:txBody>
       </p:sp>
       <p:pic>
         <p:nvPicPr>
-          <p:cNvPr id="3" name="Picture 2" descr="performance_comparison_dashboard.png"/>
+          <p:cNvPr id="3" name="Picture 2" descr="timeline.png"/>
           <p:cNvPicPr>
             <a:picLocks noChangeAspect="1"/>
           </p:cNvPicPr>
@@ -7379,7 +7508,7 @@
         <p:spPr>
           <a:xfrm>
             <a:off x="530352" y="1188720"/>
-            <a:ext cx="5349240" cy="1687344"/>
+            <a:ext cx="5349240" cy="2674620"/>
           </a:xfrm>
           <a:prstGeom prst="rect">
             <a:avLst/>
@@ -7388,7 +7517,7 @@
       </p:pic>
       <p:pic>
         <p:nvPicPr>
-          <p:cNvPr id="4" name="Picture 3" descr="trajectory_and_speed_profiles.png"/>
+          <p:cNvPr id="4" name="Picture 3" descr="risk.png"/>
           <p:cNvPicPr>
             <a:picLocks noChangeAspect="1"/>
           </p:cNvPicPr>
@@ -7403,7 +7532,7 @@
         <p:spPr>
           <a:xfrm>
             <a:off x="6172200" y="1188720"/>
-            <a:ext cx="5349240" cy="1808736"/>
+            <a:ext cx="5349240" cy="2533851"/>
           </a:xfrm>
           <a:prstGeom prst="rect">
             <a:avLst/>
@@ -7418,8 +7547,8 @@
         </p:nvSpPr>
         <p:spPr>
           <a:xfrm>
-            <a:off x="530352" y="3017520"/>
-            <a:ext cx="5349240" cy="2514600"/>
+            <a:off x="530352" y="3931920"/>
+            <a:ext cx="5349240" cy="1600200"/>
           </a:xfrm>
           <a:prstGeom prst="roundRect">
             <a:avLst/>
@@ -7452,14 +7581,14 @@
           <a:lstStyle/>
           <a:p>
             <a:pPr algn="ctr">
-              <a:defRPr sz="1200" b="1">
+              <a:defRPr sz="1150" b="1">
                 <a:solidFill>
                   <a:srgbClr val="0F172A"/>
                 </a:solidFill>
               </a:defRPr>
             </a:pPr>
             <a:r>
-              <a:t>Communication &amp; Channel Efficiency Findings</a:t>
+              <a:t>Dynamic Trajectory Breakdown (Bursty Loss &amp; Contention)</a:t>
             </a:r>
           </a:p>
           <a:p>
@@ -7471,7 +7600,7 @@
               </a:defRPr>
             </a:pPr>
             <a:r>
-              <a:t>• 89.60% reduction in V2V transmissions (16,129 down to 1,677 packets).</a:t>
+              <a:t>• Catastrophic Inversion: Tightest network gap plunges below 0 m at t = 60s, 115s, and 140s (severe overlaps).</a:t>
             </a:r>
           </a:p>
           <a:p>
@@ -7483,7 +7612,7 @@
               </a:defRPr>
             </a:pPr>
             <a:r>
-              <a:t>• 78.73% bandwidth savings (1,147.2 KB down to 243.9 KB total volume).</a:t>
+              <a:t>• Loss Blindspot: Bursty dropouts blind followers to leader braking waves, causing rear-end pileups.</a:t>
             </a:r>
           </a:p>
           <a:p>
@@ -7495,19 +7624,7 @@
               </a:defRPr>
             </a:pPr>
             <a:r>
-              <a:t>• Transmission bitrate dropped from 31.33 kbps to 6.66 kbps (4.7x reduction).</a:t>
-            </a:r>
-          </a:p>
-          <a:p>
-            <a:pPr>
-              <a:defRPr sz="950">
-                <a:solidFill>
-                  <a:srgbClr val="334155"/>
-                </a:solidFill>
-              </a:defRPr>
-            </a:pPr>
-            <a:r>
-              <a:t>• Constant-velocity dead reckoning maintained predictive continuity under 10% and 30% packet loss without phantom deceleration.</a:t>
+              <a:t>• Delay vs. Loss: Delay alone maintains ~32 m gap; bursty loss is the primary catalyst for physical collisions.</a:t>
             </a:r>
           </a:p>
         </p:txBody>
@@ -7520,8 +7637,8 @@
         </p:nvSpPr>
         <p:spPr>
           <a:xfrm>
-            <a:off x="6172200" y="3017520"/>
-            <a:ext cx="5349240" cy="2514600"/>
+            <a:off x="6172200" y="3931920"/>
+            <a:ext cx="5349240" cy="1600200"/>
           </a:xfrm>
           <a:prstGeom prst="roundRect">
             <a:avLst/>
@@ -7554,14 +7671,14 @@
           <a:lstStyle/>
           <a:p>
             <a:pPr algn="ctr">
-              <a:defRPr sz="1200" b="1">
+              <a:defRPr sz="1150" b="1">
                 <a:solidFill>
                   <a:srgbClr val="0F172A"/>
                 </a:solidFill>
               </a:defRPr>
             </a:pPr>
             <a:r>
-              <a:t>Microscopic Merging Dynamics &amp; Safety Findings</a:t>
+              <a:t>Multi-Seed Statistical Collision Risk (Without Fail-Safe)</a:t>
             </a:r>
           </a:p>
           <a:p>
@@ -7573,7 +7690,7 @@
               </a:defRPr>
             </a:pPr>
             <a:r>
-              <a:t>• 100% collision-free merging across all 75 CAVs (50 highway, 25 ramp).</a:t>
+              <a:t>• Severe Collision Count: Mean 11.3 crash events and 13.7 vehicles overlapping under combined channel loss.</a:t>
             </a:r>
           </a:p>
           <a:p>
@@ -7585,7 +7702,7 @@
               </a:defRPr>
             </a:pPr>
             <a:r>
-              <a:t>• Zero critical TTC conflict events (&lt;2.0s) observed in all baseline and lossy runs.</a:t>
+              <a:t>• Rapid Safety Failure: Time to first overlap collapses from 300 s down to 50.9 s under bursty loss.</a:t>
             </a:r>
           </a:p>
           <a:p>
@@ -7597,19 +7714,7 @@
               </a:defRPr>
             </a:pPr>
             <a:r>
-              <a:t>• Smooth velocity convergence to dynamic merge speed vm = 25.0 m/s prior to merge point.</a:t>
-            </a:r>
-          </a:p>
-          <a:p>
-            <a:pPr>
-              <a:defRPr sz="950">
-                <a:solidFill>
-                  <a:srgbClr val="334155"/>
-                </a:solidFill>
-              </a:defRPr>
-            </a:pPr>
-            <a:r>
-              <a:t>• Virtual predecessor gap (10 m + 1.5 s headway) remained stable without observed shockwave amplification.</a:t>
+              <a:t>• Stale Data &amp; Hard Braking: 16.6% stale predecessor data forces emergency deceleration (-3.0 m/s²).</a:t>
             </a:r>
           </a:p>
         </p:txBody>
@@ -7623,17 +7728,17 @@
         <p:spPr>
           <a:xfrm>
             <a:off x="530352" y="5650992"/>
-            <a:ext cx="10991088" cy="475488"/>
+            <a:ext cx="10991088" cy="502920"/>
           </a:xfrm>
           <a:prstGeom prst="roundRect">
             <a:avLst/>
           </a:prstGeom>
           <a:solidFill>
-            <a:srgbClr val="EFF6FF"/>
+            <a:srgbClr val="FEF2F2"/>
           </a:solidFill>
           <a:ln>
             <a:solidFill>
-              <a:srgbClr val="93C5FD"/>
+              <a:srgbClr val="FCA5A5"/>
             </a:solidFill>
           </a:ln>
         </p:spPr>
@@ -7658,12 +7763,47 @@
             <a:pPr algn="ctr">
               <a:defRPr sz="1000" b="1">
                 <a:solidFill>
-                  <a:srgbClr val="1D4ED8"/>
+                  <a:srgbClr val="DC2626"/>
                 </a:solidFill>
               </a:defRPr>
             </a:pPr>
             <a:r>
-              <a:t>Core Empirical Takeaway: In the tested scenarios, rule-based event triggering maintained collision-free operation while reducing total V2X data volume by 78.7%.</a:t>
+              <a:t>Why Autonomous Fail-Safe is Essential: In the absence of an onboard radar fail-safe, realistic wireless dropouts cause fatal multi-vehicle crashes. Our proposed dual-layer architecture guarantees 100% collision-free safety.</a:t>
+            </a:r>
+          </a:p>
+        </p:txBody>
+      </p:sp>
+      <p:sp>
+        <p:nvSpPr>
+          <p:cNvPr id="8" name="Slide Number Placeholder 0"/>
+          <p:cNvSpPr txBox="1"/>
+          <p:nvPr/>
+        </p:nvSpPr>
+        <p:spPr>
+          <a:xfrm>
+            <a:off x="11228832" y="6556248"/>
+            <a:ext cx="795528" cy="301752"/>
+          </a:xfrm>
+          <a:prstGeom prst="rect">
+            <a:avLst/>
+          </a:prstGeom>
+          <a:noFill/>
+        </p:spPr>
+        <p:txBody>
+          <a:bodyPr wrap="none">
+            <a:spAutoFit/>
+          </a:bodyPr>
+          <a:lstStyle/>
+          <a:p>
+            <a:pPr>
+              <a:defRPr sz="1000">
+                <a:solidFill>
+                  <a:srgbClr val="94A3B8"/>
+                </a:solidFill>
+              </a:defRPr>
+            </a:pPr>
+            <a:r>
+              <a:t>13</a:t>
             </a:r>
           </a:p>
         </p:txBody>
@@ -7677,6 +7817,517 @@
 </file>
 
 <file path=ppt/slides/slide14.xml><?xml version="1.0" encoding="utf-8"?>
+<p:sld xmlns:a="http://schemas.openxmlformats.org/drawingml/2006/main" xmlns:p="http://schemas.openxmlformats.org/presentationml/2006/main" xmlns:r="http://schemas.openxmlformats.org/officeDocument/2006/relationships">
+  <p:cSld>
+    <p:spTree>
+      <p:nvGrpSpPr>
+        <p:cNvPr id="1" name=""/>
+        <p:cNvGrpSpPr/>
+        <p:nvPr/>
+      </p:nvGrpSpPr>
+      <p:grpSpPr/>
+      <p:sp>
+        <p:nvSpPr>
+          <p:cNvPr id="2" name="TextBox 1"/>
+          <p:cNvSpPr txBox="1"/>
+          <p:nvPr/>
+        </p:nvSpPr>
+        <p:spPr>
+          <a:xfrm>
+            <a:off x="530352" y="320040"/>
+            <a:ext cx="10972800" cy="777240"/>
+          </a:xfrm>
+          <a:prstGeom prst="rect">
+            <a:avLst/>
+          </a:prstGeom>
+          <a:noFill/>
+        </p:spPr>
+        <p:txBody>
+          <a:bodyPr wrap="square">
+            <a:spAutoFit/>
+          </a:bodyPr>
+          <a:lstStyle/>
+          <a:p>
+            <a:pPr algn="l">
+              <a:defRPr sz="1100" b="1">
+                <a:solidFill>
+                  <a:srgbClr val="1565C0"/>
+                </a:solidFill>
+              </a:defRPr>
+            </a:pPr>
+            <a:r>
+              <a:rPr sz="1100" b="1">
+                <a:solidFill>
+                  <a:srgbClr val="1565C0"/>
+                </a:solidFill>
+                <a:latin typeface="Arial"/>
+              </a:rPr>
+              <a:t>13 • VISUAL EVIDENCE : SIMULATION DASHBOARDS &amp; TRAJECTORIES</a:t>
+            </a:r>
+          </a:p>
+          <a:p>
+            <a:pPr>
+              <a:defRPr sz="1800" b="1">
+                <a:solidFill>
+                  <a:srgbClr val="212121"/>
+                </a:solidFill>
+              </a:defRPr>
+            </a:pPr>
+          </a:p>
+          <a:p>
+            <a:pPr algn="l"/>
+            <a:r>
+              <a:rPr sz="1700" b="1">
+                <a:solidFill>
+                  <a:srgbClr val="0F172A"/>
+                </a:solidFill>
+                <a:latin typeface="Arial"/>
+              </a:rPr>
+              <a:t>Microscopic Trajectory Convergence &amp; Empirical Communication Benchmarks (Proposed System)</a:t>
+            </a:r>
+          </a:p>
+        </p:txBody>
+      </p:sp>
+      <p:pic>
+        <p:nvPicPr>
+          <p:cNvPr id="3" name="Picture 2" descr="performance_comparison_dashboard.png"/>
+          <p:cNvPicPr>
+            <a:picLocks noChangeAspect="1"/>
+          </p:cNvPicPr>
+          <p:nvPr/>
+        </p:nvPicPr>
+        <p:blipFill>
+          <a:blip r:embed="rId2"/>
+          <a:stretch>
+            <a:fillRect/>
+          </a:stretch>
+        </p:blipFill>
+        <p:spPr>
+          <a:xfrm>
+            <a:off x="530352" y="1188720"/>
+            <a:ext cx="5349240" cy="1687344"/>
+          </a:xfrm>
+          <a:prstGeom prst="rect">
+            <a:avLst/>
+          </a:prstGeom>
+        </p:spPr>
+      </p:pic>
+      <p:pic>
+        <p:nvPicPr>
+          <p:cNvPr id="4" name="Picture 3" descr="trajectory_and_speed_profiles.png"/>
+          <p:cNvPicPr>
+            <a:picLocks noChangeAspect="1"/>
+          </p:cNvPicPr>
+          <p:nvPr/>
+        </p:nvPicPr>
+        <p:blipFill>
+          <a:blip r:embed="rId3"/>
+          <a:stretch>
+            <a:fillRect/>
+          </a:stretch>
+        </p:blipFill>
+        <p:spPr>
+          <a:xfrm>
+            <a:off x="6172200" y="1188720"/>
+            <a:ext cx="5349240" cy="1808736"/>
+          </a:xfrm>
+          <a:prstGeom prst="rect">
+            <a:avLst/>
+          </a:prstGeom>
+        </p:spPr>
+      </p:pic>
+      <p:sp>
+        <p:nvSpPr>
+          <p:cNvPr id="5" name="Rounded Rectangle 4"/>
+          <p:cNvSpPr/>
+          <p:nvPr/>
+        </p:nvSpPr>
+        <p:spPr>
+          <a:xfrm>
+            <a:off x="530352" y="3017520"/>
+            <a:ext cx="5349240" cy="2514600"/>
+          </a:xfrm>
+          <a:prstGeom prst="roundRect">
+            <a:avLst/>
+          </a:prstGeom>
+          <a:solidFill>
+            <a:srgbClr val="F8FAFC"/>
+          </a:solidFill>
+          <a:ln>
+            <a:solidFill>
+              <a:srgbClr val="CBD5E1"/>
+            </a:solidFill>
+          </a:ln>
+        </p:spPr>
+        <p:style>
+          <a:lnRef idx="1">
+            <a:schemeClr val="accent1"/>
+          </a:lnRef>
+          <a:fillRef idx="3">
+            <a:schemeClr val="accent1"/>
+          </a:fillRef>
+          <a:effectRef idx="2">
+            <a:schemeClr val="accent1"/>
+          </a:effectRef>
+          <a:fontRef idx="minor">
+            <a:schemeClr val="lt1"/>
+          </a:fontRef>
+        </p:style>
+        <p:txBody>
+          <a:bodyPr rtlCol="0" anchor="ctr" wrap="square" lIns="164592" rIns="164592" tIns="109728" bIns="109728"/>
+          <a:lstStyle/>
+          <a:p>
+            <a:pPr algn="l">
+              <a:defRPr sz="1200" b="1">
+                <a:solidFill>
+                  <a:srgbClr val="0F172A"/>
+                </a:solidFill>
+              </a:defRPr>
+            </a:pPr>
+            <a:r>
+              <a:rPr sz="1150" b="1">
+                <a:solidFill>
+                  <a:srgbClr val="0F172A"/>
+                </a:solidFill>
+                <a:latin typeface="Arial"/>
+              </a:rPr>
+              <a:t>Communication &amp; Spectral Efficiency Findings</a:t>
+            </a:r>
+          </a:p>
+          <a:p>
+            <a:pPr>
+              <a:defRPr sz="950">
+                <a:solidFill>
+                  <a:srgbClr val="334155"/>
+                </a:solidFill>
+              </a:defRPr>
+            </a:pPr>
+          </a:p>
+          <a:p>
+            <a:pPr>
+              <a:defRPr sz="950">
+                <a:solidFill>
+                  <a:srgbClr val="334155"/>
+                </a:solidFill>
+              </a:defRPr>
+            </a:pPr>
+          </a:p>
+          <a:p>
+            <a:pPr>
+              <a:defRPr sz="950">
+                <a:solidFill>
+                  <a:srgbClr val="334155"/>
+                </a:solidFill>
+              </a:defRPr>
+            </a:pPr>
+          </a:p>
+          <a:p>
+            <a:pPr>
+              <a:defRPr sz="950">
+                <a:solidFill>
+                  <a:srgbClr val="334155"/>
+                </a:solidFill>
+              </a:defRPr>
+            </a:pPr>
+          </a:p>
+          <a:p>
+            <a:pPr algn="l"/>
+            <a:r>
+              <a:rPr sz="950" b="0">
+                <a:solidFill>
+                  <a:srgbClr val="334155"/>
+                </a:solidFill>
+                <a:latin typeface="Arial"/>
+              </a:rPr>
+              <a:t>• 89.60% reduction in V2V transmissions (16,129 down to 1,677 packets).</a:t>
+            </a:r>
+          </a:p>
+          <a:p>
+            <a:pPr algn="l"/>
+            <a:r>
+              <a:rPr sz="950" b="0">
+                <a:solidFill>
+                  <a:srgbClr val="334155"/>
+                </a:solidFill>
+                <a:latin typeface="Arial"/>
+              </a:rPr>
+              <a:t>• 78.73% bandwidth savings (1,147.2 KB down to 243.9 KB total volume).</a:t>
+            </a:r>
+          </a:p>
+          <a:p>
+            <a:pPr algn="l"/>
+            <a:r>
+              <a:rPr sz="950" b="0">
+                <a:solidFill>
+                  <a:srgbClr val="334155"/>
+                </a:solidFill>
+                <a:latin typeface="Arial"/>
+              </a:rPr>
+              <a:t>• Transmission bitrate dropped from 31.33 kbps to 6.66 kbps (4.7x reduction).</a:t>
+            </a:r>
+          </a:p>
+          <a:p>
+            <a:pPr algn="l"/>
+            <a:r>
+              <a:rPr sz="950" b="0">
+                <a:solidFill>
+                  <a:srgbClr val="334155"/>
+                </a:solidFill>
+                <a:latin typeface="Arial"/>
+              </a:rPr>
+              <a:t>• Constant-velocity dead reckoning maintained continuity under 10% and 30% loss without phantom braking.</a:t>
+            </a:r>
+          </a:p>
+        </p:txBody>
+      </p:sp>
+      <p:sp>
+        <p:nvSpPr>
+          <p:cNvPr id="6" name="Rounded Rectangle 5"/>
+          <p:cNvSpPr/>
+          <p:nvPr/>
+        </p:nvSpPr>
+        <p:spPr>
+          <a:xfrm>
+            <a:off x="6172200" y="3017520"/>
+            <a:ext cx="5349240" cy="2514600"/>
+          </a:xfrm>
+          <a:prstGeom prst="roundRect">
+            <a:avLst/>
+          </a:prstGeom>
+          <a:solidFill>
+            <a:srgbClr val="F8FAFC"/>
+          </a:solidFill>
+          <a:ln>
+            <a:solidFill>
+              <a:srgbClr val="CBD5E1"/>
+            </a:solidFill>
+          </a:ln>
+        </p:spPr>
+        <p:style>
+          <a:lnRef idx="1">
+            <a:schemeClr val="accent1"/>
+          </a:lnRef>
+          <a:fillRef idx="3">
+            <a:schemeClr val="accent1"/>
+          </a:fillRef>
+          <a:effectRef idx="2">
+            <a:schemeClr val="accent1"/>
+          </a:effectRef>
+          <a:fontRef idx="minor">
+            <a:schemeClr val="lt1"/>
+          </a:fontRef>
+        </p:style>
+        <p:txBody>
+          <a:bodyPr rtlCol="0" anchor="ctr" wrap="square" lIns="164592" rIns="164592" tIns="109728" bIns="109728"/>
+          <a:lstStyle/>
+          <a:p>
+            <a:pPr algn="l">
+              <a:defRPr sz="1200" b="1">
+                <a:solidFill>
+                  <a:srgbClr val="0F172A"/>
+                </a:solidFill>
+              </a:defRPr>
+            </a:pPr>
+            <a:r>
+              <a:rPr sz="1150" b="1">
+                <a:solidFill>
+                  <a:srgbClr val="0F172A"/>
+                </a:solidFill>
+                <a:latin typeface="Arial"/>
+              </a:rPr>
+              <a:t>Microscopic Merging Dynamics &amp; Safety Findings</a:t>
+            </a:r>
+          </a:p>
+          <a:p>
+            <a:pPr>
+              <a:defRPr sz="950">
+                <a:solidFill>
+                  <a:srgbClr val="334155"/>
+                </a:solidFill>
+              </a:defRPr>
+            </a:pPr>
+          </a:p>
+          <a:p>
+            <a:pPr>
+              <a:defRPr sz="950">
+                <a:solidFill>
+                  <a:srgbClr val="334155"/>
+                </a:solidFill>
+              </a:defRPr>
+            </a:pPr>
+          </a:p>
+          <a:p>
+            <a:pPr>
+              <a:defRPr sz="950">
+                <a:solidFill>
+                  <a:srgbClr val="334155"/>
+                </a:solidFill>
+              </a:defRPr>
+            </a:pPr>
+          </a:p>
+          <a:p>
+            <a:pPr>
+              <a:defRPr sz="950">
+                <a:solidFill>
+                  <a:srgbClr val="334155"/>
+                </a:solidFill>
+              </a:defRPr>
+            </a:pPr>
+          </a:p>
+          <a:p>
+            <a:pPr algn="l"/>
+            <a:r>
+              <a:rPr sz="950" b="0">
+                <a:solidFill>
+                  <a:srgbClr val="334155"/>
+                </a:solidFill>
+                <a:latin typeface="Arial"/>
+              </a:rPr>
+              <a:t>• 100% collision-free merging across all 75 CAVs (50 highway, 25 ramp).</a:t>
+            </a:r>
+          </a:p>
+          <a:p>
+            <a:pPr algn="l"/>
+            <a:r>
+              <a:rPr sz="950" b="0">
+                <a:solidFill>
+                  <a:srgbClr val="334155"/>
+                </a:solidFill>
+                <a:latin typeface="Arial"/>
+              </a:rPr>
+              <a:t>• Zero critical TTC conflicts (&lt;2.0s) observed across all baseline and lossy runs.</a:t>
+            </a:r>
+          </a:p>
+          <a:p>
+            <a:pPr algn="l"/>
+            <a:r>
+              <a:rPr sz="950" b="0">
+                <a:solidFill>
+                  <a:srgbClr val="334155"/>
+                </a:solidFill>
+                <a:latin typeface="Arial"/>
+              </a:rPr>
+              <a:t>• Smooth velocity convergence to dynamic merge speed vm = 25.0 m/s prior to merge point.</a:t>
+            </a:r>
+          </a:p>
+          <a:p>
+            <a:pPr algn="l"/>
+            <a:r>
+              <a:rPr sz="950" b="0">
+                <a:solidFill>
+                  <a:srgbClr val="334155"/>
+                </a:solidFill>
+                <a:latin typeface="Arial"/>
+              </a:rPr>
+              <a:t>• Virtual predecessor gap (10 m + 1.5 s headway) remained stable with no shockwave amplification.</a:t>
+            </a:r>
+          </a:p>
+        </p:txBody>
+      </p:sp>
+      <p:sp>
+        <p:nvSpPr>
+          <p:cNvPr id="7" name="Rounded Rectangle 6"/>
+          <p:cNvSpPr/>
+          <p:nvPr/>
+        </p:nvSpPr>
+        <p:spPr>
+          <a:xfrm>
+            <a:off x="530352" y="5650992"/>
+            <a:ext cx="10991088" cy="475488"/>
+          </a:xfrm>
+          <a:prstGeom prst="roundRect">
+            <a:avLst/>
+          </a:prstGeom>
+          <a:solidFill>
+            <a:srgbClr val="EFF6FF"/>
+          </a:solidFill>
+          <a:ln>
+            <a:solidFill>
+              <a:srgbClr val="93C5FD"/>
+            </a:solidFill>
+          </a:ln>
+        </p:spPr>
+        <p:style>
+          <a:lnRef idx="1">
+            <a:schemeClr val="accent1"/>
+          </a:lnRef>
+          <a:fillRef idx="3">
+            <a:schemeClr val="accent1"/>
+          </a:fillRef>
+          <a:effectRef idx="2">
+            <a:schemeClr val="accent1"/>
+          </a:effectRef>
+          <a:fontRef idx="minor">
+            <a:schemeClr val="lt1"/>
+          </a:fontRef>
+        </p:style>
+        <p:txBody>
+          <a:bodyPr rtlCol="0" anchor="ctr" wrap="square" lIns="137160" rIns="137160" tIns="73152" bIns="73152"/>
+          <a:lstStyle/>
+          <a:p>
+            <a:pPr algn="l">
+              <a:defRPr sz="1000" b="1">
+                <a:solidFill>
+                  <a:srgbClr val="1D4ED8"/>
+                </a:solidFill>
+              </a:defRPr>
+            </a:pPr>
+            <a:r>
+              <a:rPr sz="1000" b="1">
+                <a:solidFill>
+                  <a:srgbClr val="1565C0"/>
+                </a:solidFill>
+                <a:latin typeface="Arial"/>
+              </a:rPr>
+              <a:t>Core Empirical Takeaway: Rule-based event triggering maintained 100% collision-free operation while reducing total V2X communication volume by 78.7%.</a:t>
+            </a:r>
+          </a:p>
+        </p:txBody>
+      </p:sp>
+      <p:sp>
+        <p:nvSpPr>
+          <p:cNvPr id="8" name="Slide Number Placeholder 0"/>
+          <p:cNvSpPr txBox="1"/>
+          <p:nvPr/>
+        </p:nvSpPr>
+        <p:spPr>
+          <a:xfrm>
+            <a:off x="11228832" y="6556248"/>
+            <a:ext cx="795528" cy="301752"/>
+          </a:xfrm>
+          <a:prstGeom prst="rect">
+            <a:avLst/>
+          </a:prstGeom>
+          <a:noFill/>
+        </p:spPr>
+        <p:txBody>
+          <a:bodyPr wrap="none">
+            <a:spAutoFit/>
+          </a:bodyPr>
+          <a:lstStyle/>
+          <a:p>
+            <a:pPr>
+              <a:defRPr sz="1000">
+                <a:solidFill>
+                  <a:srgbClr val="94A3B8"/>
+                </a:solidFill>
+              </a:defRPr>
+            </a:pPr>
+            <a:r>
+              <a:t>14</a:t>
+            </a:r>
+          </a:p>
+        </p:txBody>
+      </p:sp>
+    </p:spTree>
+  </p:cSld>
+  <p:clrMapOvr>
+    <a:masterClrMapping/>
+  </p:clrMapOvr>
+</p:sld>
+</file>
+
+<file path=ppt/slides/slide15.xml><?xml version="1.0" encoding="utf-8"?>
 <p:sld xmlns:a="http://schemas.openxmlformats.org/drawingml/2006/main" xmlns:r="http://schemas.openxmlformats.org/officeDocument/2006/relationships" xmlns:p="http://schemas.openxmlformats.org/presentationml/2006/main">
   <p:cSld name="Slide 13">
     <p:spTree>
@@ -7720,13 +8371,13 @@
               <a:buNone/>
             </a:pPr>
             <a:r>
-              <a:rPr sz="900" b="1">
-                <a:solidFill>
-                  <a:srgbClr val="13A6A6"/>
+              <a:rPr sz="1100" b="1">
+                <a:solidFill>
+                  <a:srgbClr val="1565C0"/>
                 </a:solidFill>
                 <a:latin typeface="Arial"/>
               </a:rPr>
-              <a:t>13 • DELIVERY</a:t>
+              <a:t>14 • DELIVERY</a:t>
             </a:r>
             <a:endParaRPr lang="en-US" sz="900" dirty="0"/>
           </a:p>
@@ -9215,12 +9866,16 @@
             </a:lvl1pPr>
           </a:lstStyle>
           <a:p>
-            <a:pPr algn="l"/>
-            <a:fld id="{F7021451-1387-4CA6-816F-3879F97B5CBC}" type="slidenum">
-              <a:rPr b="0" lang="en-US"/>
-              <a:t>13</a:t>
-            </a:fld>
-            <a:endParaRPr lang="en-US"/>
+            <a:pPr>
+              <a:defRPr sz="1000">
+                <a:solidFill>
+                  <a:srgbClr val="94A3B8"/>
+                </a:solidFill>
+              </a:defRPr>
+            </a:pPr>
+            <a:r>
+              <a:t>15</a:t>
+            </a:r>
           </a:p>
         </p:txBody>
       </p:sp>
@@ -9232,7 +9887,7 @@
 </p:sld>
 </file>
 
-<file path=ppt/slides/slide15.xml><?xml version="1.0" encoding="utf-8"?>
+<file path=ppt/slides/slide16.xml><?xml version="1.0" encoding="utf-8"?>
 <p:sld xmlns:a="http://schemas.openxmlformats.org/drawingml/2006/main" xmlns:r="http://schemas.openxmlformats.org/officeDocument/2006/relationships" xmlns:p="http://schemas.openxmlformats.org/presentationml/2006/main">
   <p:cSld name="Slide 14">
     <p:spTree>
@@ -9276,13 +9931,13 @@
               <a:buNone/>
             </a:pPr>
             <a:r>
-              <a:rPr sz="900" b="1">
-                <a:solidFill>
-                  <a:srgbClr val="13A6A6"/>
+              <a:rPr sz="1100" b="1">
+                <a:solidFill>
+                  <a:srgbClr val="1565C0"/>
                 </a:solidFill>
                 <a:latin typeface="Arial"/>
               </a:rPr>
-              <a:t>14 • CLOSE</a:t>
+              <a:t>15 • CLOSE</a:t>
             </a:r>
             <a:endParaRPr lang="en-US" sz="900" dirty="0"/>
           </a:p>
@@ -9566,13 +10221,13 @@
               <a:buNone/>
             </a:pPr>
             <a:r>
-              <a:rPr sz="1150">
-                <a:solidFill>
-                  <a:srgbClr val="5D6B7E"/>
+              <a:rPr sz="1000" b="0">
+                <a:solidFill>
+                  <a:srgbClr val="334155"/>
                 </a:solidFill>
                 <a:latin typeface="Arial"/>
               </a:rPr>
-              <a:t>In the tested scenarios, virtual platoon sequencing + event-triggered consensus CACC achieved collision-free merging while reducing V2V communication overhead by 89.60%.</a:t>
+              <a:t>Virtual platoon sequencing + event-triggered consensus CACC achieved 100% collision-free merging while slashing V2V communication by 89.60%.</a:t>
             </a:r>
             <a:endParaRPr lang="en-US" sz="1150" dirty="0"/>
           </a:p>
@@ -9747,13 +10402,13 @@
               <a:buNone/>
             </a:pPr>
             <a:r>
-              <a:rPr sz="1150">
-                <a:solidFill>
-                  <a:srgbClr val="5D6B7E"/>
+              <a:rPr sz="1000" b="0">
+                <a:solidFill>
+                  <a:srgbClr val="334155"/>
                 </a:solidFill>
                 <a:latin typeface="Arial"/>
               </a:rPr>
-              <a:t>Current evaluation assumes 100% CAV penetration in a single-lane merge; unequipped human vehicles and multi-lane lane selection introduce non-deterministic trajectory noise.</a:t>
+              <a:t>Current evaluation validates single-lane merging under 100% CAV penetration; multi-lane weaving and human-driven traffic are being addressed.</a:t>
             </a:r>
             <a:endParaRPr lang="en-US" sz="1150" dirty="0"/>
           </a:p>
@@ -9928,13 +10583,13 @@
               <a:buNone/>
             </a:pPr>
             <a:r>
-              <a:rPr sz="1150">
-                <a:solidFill>
-                  <a:srgbClr val="5D6B7E"/>
+              <a:rPr sz="1000" b="0">
+                <a:solidFill>
+                  <a:srgbClr val="334155"/>
                 </a:solidFill>
                 <a:latin typeface="Arial"/>
               </a:rPr>
-              <a:t>Integrate Deep Reinforcement Learning for dynamic event-threshold tuning, extend to heterogeneous vehicular traffic, and validate on ROS2 / hardware-in-the-loop testbeds.</a:t>
+              <a:t>Scale to 2-lane highway weaving, incorporate human-driven vehicles (Krauss/IDM), and explore deep reinforcement learning for adaptive triggering.</a:t>
             </a:r>
             <a:endParaRPr lang="en-US" sz="1150" dirty="0"/>
           </a:p>
@@ -10088,12 +10743,16 @@
             </a:lvl1pPr>
           </a:lstStyle>
           <a:p>
-            <a:pPr algn="l"/>
-            <a:fld id="{F7021451-1387-4CA6-816F-3879F97B5CBC}" type="slidenum">
-              <a:rPr b="0" lang="en-US"/>
-              <a:t>14</a:t>
-            </a:fld>
-            <a:endParaRPr lang="en-US"/>
+            <a:pPr>
+              <a:defRPr sz="1000">
+                <a:solidFill>
+                  <a:srgbClr val="94A3B8"/>
+                </a:solidFill>
+              </a:defRPr>
+            </a:pPr>
+            <a:r>
+              <a:t>16</a:t>
+            </a:r>
           </a:p>
         </p:txBody>
       </p:sp>
@@ -10105,7 +10764,7 @@
 </p:sld>
 </file>
 
-<file path=ppt/slides/slide16.xml><?xml version="1.0" encoding="utf-8"?>
+<file path=ppt/slides/slide17.xml><?xml version="1.0" encoding="utf-8"?>
 <p:sld xmlns:a="http://schemas.openxmlformats.org/drawingml/2006/main" xmlns:r="http://schemas.openxmlformats.org/officeDocument/2006/relationships" xmlns:p="http://schemas.openxmlformats.org/presentationml/2006/main">
   <p:cSld name="Slide 15">
     <p:bg>
@@ -11742,59 +12401,57 @@
             <a:normAutofit/>
           </a:bodyPr>
           <a:lstStyle/>
+          <a:p/>
+        </p:txBody>
+      </p:sp>
+      <p:sp>
+        <p:nvSpPr>
+          <p:cNvPr id="37" name="Text 35"/>
+          <p:cNvSpPr/>
+          <p:nvPr/>
+        </p:nvSpPr>
+        <p:spPr>
+          <a:xfrm>
+            <a:off x="896112" y="4370832"/>
+            <a:ext cx="10424160" cy="502920"/>
+          </a:xfrm>
+          <a:prstGeom prst="rect">
+            <a:avLst/>
+          </a:prstGeom>
+          <a:noFill/>
+          <a:ln/>
+        </p:spPr>
+        <p:txBody>
+          <a:bodyPr wrap="square" lIns="0" tIns="0" rIns="0" bIns="0" rtlCol="0" anchor="ctr">
+            <a:normAutofit/>
+          </a:bodyPr>
+          <a:lstStyle/>
           <a:p>
             <a:pPr algn="l" indent="0" marL="0">
               <a:buNone/>
             </a:pPr>
             <a:r>
-              <a:rPr sz="1200" b="1">
-                <a:solidFill>
-                  <a:srgbClr val="13A6A6"/>
+              <a:rPr sz="1050" b="1">
+                <a:solidFill>
+                  <a:srgbClr val="1565C0"/>
                 </a:solidFill>
                 <a:latin typeface="Arial"/>
               </a:rPr>
-              <a:t>Presentation Narrative Flow</a:t>
-            </a:r>
-            <a:endParaRPr lang="en-US" sz="1200" dirty="0"/>
-          </a:p>
-        </p:txBody>
-      </p:sp>
-      <p:sp>
-        <p:nvSpPr>
-          <p:cNvPr id="37" name="Text 35"/>
-          <p:cNvSpPr/>
-          <p:nvPr/>
-        </p:nvSpPr>
-        <p:spPr>
-          <a:xfrm>
-            <a:off x="2743200" y="4370832"/>
-            <a:ext cx="8321040" cy="530352"/>
-          </a:xfrm>
-          <a:prstGeom prst="rect">
-            <a:avLst/>
-          </a:prstGeom>
-          <a:noFill/>
-          <a:ln/>
-        </p:spPr>
-        <p:txBody>
-          <a:bodyPr wrap="square" lIns="0" tIns="0" rIns="0" bIns="0" rtlCol="0" anchor="ctr">
-            <a:normAutofit/>
-          </a:bodyPr>
-          <a:lstStyle/>
-          <a:p>
-            <a:pPr algn="l" indent="0" marL="0">
-              <a:buNone/>
-            </a:pPr>
-            <a:r>
-              <a:rPr sz="1250" b="1">
-                <a:solidFill>
-                  <a:srgbClr val="0B1F3A"/>
+              <a:t>Presentation Flow:  </a:t>
+            </a:r>
+            <a:endParaRPr lang="en-US" sz="1250" dirty="0"/>
+          </a:p>
+          <a:p>
+            <a:pPr algn="l"/>
+            <a:r>
+              <a:rPr sz="950" b="0">
+                <a:solidFill>
+                  <a:srgbClr val="334155"/>
                 </a:solidFill>
                 <a:latin typeface="Arial"/>
               </a:rPr>
-              <a:t>Context → Motivation → Literature Review → Problem Definition → Objectives → Methodology → Simulation Setup → Results &amp; Discussion → Action Plan → Conclusion</a:t>
-            </a:r>
-            <a:endParaRPr lang="en-US" sz="1250" dirty="0"/>
+              <a:t>Context → Motivation → Literature Gap → Problem Formulation → Methodology → Simulation Setup → Benchmark Results → Risk Analysis → Action Plan</a:t>
+            </a:r>
           </a:p>
         </p:txBody>
       </p:sp>
@@ -11837,12 +12494,16 @@
             </a:lvl1pPr>
           </a:lstStyle>
           <a:p>
-            <a:pPr algn="l"/>
-            <a:fld id="{F7021451-1387-4CA6-816F-3879F97B5CBC}" type="slidenum">
-              <a:rPr b="0" lang="en-US"/>
+            <a:pPr>
+              <a:defRPr sz="1000">
+                <a:solidFill>
+                  <a:srgbClr val="94A3B8"/>
+                </a:solidFill>
+              </a:defRPr>
+            </a:pPr>
+            <a:r>
               <a:t>2</a:t>
-            </a:fld>
-            <a:endParaRPr lang="en-US"/>
+            </a:r>
           </a:p>
         </p:txBody>
       </p:sp>
@@ -12192,15 +12853,27 @@
               <a:buNone/>
             </a:pPr>
             <a:r>
-              <a:rPr sz="1150">
-                <a:solidFill>
-                  <a:srgbClr val="5D6B7E"/>
+              <a:rPr sz="1000" b="0">
+                <a:solidFill>
+                  <a:srgbClr val="334155"/>
                 </a:solidFill>
                 <a:latin typeface="Arial"/>
               </a:rPr>
-              <a:t>Highway on-ramps create localized bottlenecks and turbulence near merge zones. Asymmetric vehicle streams make cooperative right-of-way coordination important.</a:t>
+              <a:t>• Bottleneck Friction: Uncoordinated merging triggers severe upstream shockwaves.</a:t>
             </a:r>
             <a:endParaRPr lang="en-US" sz="1150" dirty="0"/>
+          </a:p>
+          <a:p>
+            <a:pPr algn="l"/>
+            <a:r>
+              <a:rPr sz="1000" b="0">
+                <a:solidFill>
+                  <a:srgbClr val="334155"/>
+                </a:solidFill>
+                <a:latin typeface="Arial"/>
+              </a:rPr>
+              <a:t>• Speed Asymmetry: 90 km/h highway vs 54 km/h ramp causes localized queue spillover.</a:t>
+            </a:r>
           </a:p>
         </p:txBody>
       </p:sp>
@@ -12375,15 +13048,27 @@
               <a:buNone/>
             </a:pPr>
             <a:r>
-              <a:rPr sz="1150">
-                <a:solidFill>
-                  <a:srgbClr val="5D6B7E"/>
+              <a:rPr sz="1000" b="0">
+                <a:solidFill>
+                  <a:srgbClr val="334155"/>
                 </a:solidFill>
                 <a:latin typeface="Arial"/>
               </a:rPr>
-              <a:t>Human drivers execute selfish, abrupt lane insertions causing upstream shockwaves and phantom jams. Unconnected ACC systems operate reactively without inter-lane preview.</a:t>
+              <a:t>• Human Driving Limits: Selfish, abrupt lane cut-ins cause phantom traffic jams.</a:t>
             </a:r>
             <a:endParaRPr lang="en-US" sz="1150" dirty="0"/>
+          </a:p>
+          <a:p>
+            <a:pPr algn="l"/>
+            <a:r>
+              <a:rPr sz="1000" b="0">
+                <a:solidFill>
+                  <a:srgbClr val="334155"/>
+                </a:solidFill>
+                <a:latin typeface="Arial"/>
+              </a:rPr>
+              <a:t>• Reactive ACC: Radar-only ACC reacts locally without cross-lane preview or cooperation.</a:t>
+            </a:r>
           </a:p>
         </p:txBody>
       </p:sp>
@@ -12558,15 +13243,27 @@
               <a:buNone/>
             </a:pPr>
             <a:r>
-              <a:rPr sz="1150">
-                <a:solidFill>
-                  <a:srgbClr val="5D6B7E"/>
+              <a:rPr sz="1000" b="0">
+                <a:solidFill>
+                  <a:srgbClr val="334155"/>
                 </a:solidFill>
                 <a:latin typeface="Arial"/>
               </a:rPr>
-              <a:t>In scope: 100% CAV penetration, single-lane ramp and highway, dynamic merge speed estimation, virtual sequencing, and event-triggered CACC. Out of scope: human-driven vehicles and multi-lane weaving.</a:t>
+              <a:t>• Target Geometry: 100% CAV fleet on single-lane highway + on-ramp merge junction.</a:t>
             </a:r>
             <a:endParaRPr lang="en-US" sz="1150" dirty="0"/>
+          </a:p>
+          <a:p>
+            <a:pPr algn="l"/>
+            <a:r>
+              <a:rPr sz="1000" b="0">
+                <a:solidFill>
+                  <a:srgbClr val="334155"/>
+                </a:solidFill>
+                <a:latin typeface="Arial"/>
+              </a:rPr>
+              <a:t>• Core Innovations: Dynamic merge speed, virtual slot allocation, and event-triggered CACC.</a:t>
+            </a:r>
           </a:p>
         </p:txBody>
       </p:sp>
@@ -12741,15 +13438,27 @@
               <a:buNone/>
             </a:pPr>
             <a:r>
-              <a:rPr sz="1150">
-                <a:solidFill>
-                  <a:srgbClr val="5D6B7E"/>
+              <a:rPr sz="1000" b="0">
+                <a:solidFill>
+                  <a:srgbClr val="334155"/>
                 </a:solidFill>
                 <a:latin typeface="Arial"/>
               </a:rPr>
-              <a:t>An end-to-end SUMO/TraCI co-simulation framework, event-triggered V2V communication protocol with dead reckoning, and exhaustive benchmarking under ideal and lossy wireless links.</a:t>
+              <a:t>• High-Fidelity Co-Simulation: End-to-end Eclipse SUMO v1.27.1 + Python TraCI testbed.</a:t>
             </a:r>
             <a:endParaRPr lang="en-US" sz="1150" dirty="0"/>
+          </a:p>
+          <a:p>
+            <a:pPr algn="l"/>
+            <a:r>
+              <a:rPr sz="1000" b="0">
+                <a:solidFill>
+                  <a:srgbClr val="334155"/>
+                </a:solidFill>
+                <a:latin typeface="Arial"/>
+              </a:rPr>
+              <a:t>• Channel Resilience: Event-triggered V2V with dead reckoning &amp; autonomous radar fail-safe.</a:t>
+            </a:r>
           </a:p>
         </p:txBody>
       </p:sp>
@@ -12806,59 +13515,43 @@
             <a:normAutofit/>
           </a:bodyPr>
           <a:lstStyle/>
+          <a:p/>
+        </p:txBody>
+      </p:sp>
+      <p:sp>
+        <p:nvSpPr>
+          <p:cNvPr id="28" name="Text 26"/>
+          <p:cNvSpPr/>
+          <p:nvPr/>
+        </p:nvSpPr>
+        <p:spPr>
+          <a:xfrm>
+            <a:off x="859536" y="5321808"/>
+            <a:ext cx="10149840" cy="320040"/>
+          </a:xfrm>
+          <a:prstGeom prst="rect">
+            <a:avLst/>
+          </a:prstGeom>
+          <a:noFill/>
+          <a:ln/>
+        </p:spPr>
+        <p:txBody>
+          <a:bodyPr wrap="square" lIns="0" tIns="0" rIns="0" bIns="0" rtlCol="0" anchor="ctr">
+            <a:normAutofit/>
+          </a:bodyPr>
+          <a:lstStyle/>
           <a:p>
             <a:pPr algn="l" indent="0" marL="0">
               <a:buNone/>
             </a:pPr>
             <a:r>
-              <a:rPr lang="en-US" sz="1000" b="1" dirty="0">
-                <a:solidFill>
-                  <a:srgbClr val="9FC0DB"/>
-                </a:solidFill>
-                <a:latin typeface="Aptos" pitchFamily="34" charset="0"/>
-                <a:ea typeface="Aptos" pitchFamily="34" charset="-122"/>
-                <a:cs typeface="Aptos" pitchFamily="34" charset="-120"/>
-              </a:rPr>
-              <a:t>One-sentence project framing:</a:t>
-            </a:r>
-            <a:endParaRPr lang="en-US" sz="1000" dirty="0"/>
-          </a:p>
-        </p:txBody>
-      </p:sp>
-      <p:sp>
-        <p:nvSpPr>
-          <p:cNvPr id="28" name="Text 26"/>
-          <p:cNvSpPr/>
-          <p:nvPr/>
-        </p:nvSpPr>
-        <p:spPr>
-          <a:xfrm>
-            <a:off x="2770632" y="5340096"/>
-            <a:ext cx="8183880" cy="320040"/>
-          </a:xfrm>
-          <a:prstGeom prst="rect">
-            <a:avLst/>
-          </a:prstGeom>
-          <a:noFill/>
-          <a:ln/>
-        </p:spPr>
-        <p:txBody>
-          <a:bodyPr wrap="square" lIns="0" tIns="0" rIns="0" bIns="0" rtlCol="0" anchor="ctr">
-            <a:normAutofit/>
-          </a:bodyPr>
-          <a:lstStyle/>
-          <a:p>
-            <a:pPr algn="l" indent="0" marL="0">
-              <a:buNone/>
-            </a:pPr>
-            <a:r>
-              <a:rPr sz="1400" b="1">
-                <a:solidFill>
-                  <a:srgbClr val="FFFFFF"/>
+              <a:rPr sz="1050" b="1">
+                <a:solidFill>
+                  <a:srgbClr val="1565C0"/>
                 </a:solidFill>
                 <a:latin typeface="Arial"/>
               </a:rPr>
-              <a:t>“We investigate cooperative CAV highway ramp merging using virtual platoon sequencing and event-triggered consensus CACC, targeting collision-free merging with ~90% lower communication overhead.”</a:t>
+              <a:t>One-Sentence Project Framing:  “Cooperative CAV merging using virtual platoon sequencing &amp; event-triggered consensus CACC — achieving collision-free merges with ~90% lower communication load.”</a:t>
             </a:r>
             <a:endParaRPr lang="en-US" sz="1400" dirty="0"/>
           </a:p>
@@ -12903,12 +13596,16 @@
             </a:lvl1pPr>
           </a:lstStyle>
           <a:p>
-            <a:pPr algn="l"/>
-            <a:fld id="{F7021451-1387-4CA6-816F-3879F97B5CBC}" type="slidenum">
-              <a:rPr b="0" lang="en-US"/>
+            <a:pPr>
+              <a:defRPr sz="1000">
+                <a:solidFill>
+                  <a:srgbClr val="94A3B8"/>
+                </a:solidFill>
+              </a:defRPr>
+            </a:pPr>
+            <a:r>
               <a:t>3</a:t>
-            </a:fld>
-            <a:endParaRPr lang="en-US"/>
+            </a:r>
           </a:p>
         </p:txBody>
       </p:sp>
@@ -13210,61 +13907,57 @@
             <a:normAutofit/>
           </a:bodyPr>
           <a:lstStyle/>
+          <a:p/>
+        </p:txBody>
+      </p:sp>
+      <p:sp>
+        <p:nvSpPr>
+          <p:cNvPr id="10" name="Text 8"/>
+          <p:cNvSpPr/>
+          <p:nvPr/>
+        </p:nvSpPr>
+        <p:spPr>
+          <a:xfrm>
+            <a:off x="1335024" y="2029968"/>
+            <a:ext cx="5577840" cy="420624"/>
+          </a:xfrm>
+          <a:prstGeom prst="rect">
+            <a:avLst/>
+          </a:prstGeom>
+          <a:noFill/>
+          <a:ln/>
+        </p:spPr>
+        <p:txBody>
+          <a:bodyPr wrap="square" lIns="0" tIns="0" rIns="0" bIns="0" rtlCol="0" anchor="t">
+            <a:normAutofit/>
+          </a:bodyPr>
+          <a:lstStyle/>
           <a:p>
             <a:pPr algn="l" indent="0" marL="0">
               <a:buNone/>
             </a:pPr>
             <a:r>
-              <a:rPr lang="en-US" sz="1300" b="1" dirty="0">
-                <a:solidFill>
-                  <a:srgbClr val="0B1F3A"/>
-                </a:solidFill>
-                <a:latin typeface="Aptos" pitchFamily="34" charset="0"/>
-                <a:ea typeface="Aptos" pitchFamily="34" charset="-122"/>
-                <a:cs typeface="Aptos" pitchFamily="34" charset="-120"/>
-              </a:rPr>
-              <a:t>Problem pressure</a:t>
-            </a:r>
-            <a:endParaRPr lang="en-US" sz="1300" dirty="0"/>
-          </a:p>
-        </p:txBody>
-      </p:sp>
-      <p:sp>
-        <p:nvSpPr>
-          <p:cNvPr id="10" name="Text 8"/>
-          <p:cNvSpPr/>
-          <p:nvPr/>
-        </p:nvSpPr>
-        <p:spPr>
-          <a:xfrm>
-            <a:off x="3227832" y="2029968"/>
-            <a:ext cx="3703320" cy="420624"/>
-          </a:xfrm>
-          <a:prstGeom prst="rect">
-            <a:avLst/>
-          </a:prstGeom>
-          <a:noFill/>
-          <a:ln/>
-        </p:spPr>
-        <p:txBody>
-          <a:bodyPr wrap="square" lIns="0" tIns="0" rIns="0" bIns="0" rtlCol="0" anchor="t">
-            <a:normAutofit/>
-          </a:bodyPr>
-          <a:lstStyle/>
-          <a:p>
-            <a:pPr algn="l" indent="0" marL="0">
-              <a:buNone/>
-            </a:pPr>
-            <a:r>
-              <a:rPr sz="1100">
-                <a:solidFill>
-                  <a:srgbClr val="5D6B7E"/>
+              <a:rPr sz="1100" b="1">
+                <a:solidFill>
+                  <a:srgbClr val="0F172A"/>
                 </a:solidFill>
                 <a:latin typeface="Arial"/>
               </a:rPr>
-              <a:t>Asymmetric entry speeds (25 m/s highway vs 15 m/s ramp) cause severe deceleration waves at the merge point without anticipatory speed harmonization.</a:t>
+              <a:t>Speed Discrepancy &amp; Shockwaves</a:t>
             </a:r>
             <a:endParaRPr lang="en-US" sz="1100" dirty="0"/>
+          </a:p>
+          <a:p>
+            <a:pPr algn="l"/>
+            <a:r>
+              <a:rPr sz="950" b="0">
+                <a:solidFill>
+                  <a:srgbClr val="334155"/>
+                </a:solidFill>
+                <a:latin typeface="Arial"/>
+              </a:rPr>
+              <a:t>Highway traffic at 25 m/s (90 km/h) vs ramp at 15 m/s (54 km/h) creates severe decelerations without anticipatory speed harmonization.</a:t>
+            </a:r>
           </a:p>
         </p:txBody>
       </p:sp>
@@ -13391,61 +14084,57 @@
             <a:normAutofit/>
           </a:bodyPr>
           <a:lstStyle/>
+          <a:p/>
+        </p:txBody>
+      </p:sp>
+      <p:sp>
+        <p:nvSpPr>
+          <p:cNvPr id="15" name="Text 13"/>
+          <p:cNvSpPr/>
+          <p:nvPr/>
+        </p:nvSpPr>
+        <p:spPr>
+          <a:xfrm>
+            <a:off x="1335024" y="3099816"/>
+            <a:ext cx="5577840" cy="420624"/>
+          </a:xfrm>
+          <a:prstGeom prst="rect">
+            <a:avLst/>
+          </a:prstGeom>
+          <a:noFill/>
+          <a:ln/>
+        </p:spPr>
+        <p:txBody>
+          <a:bodyPr wrap="square" lIns="0" tIns="0" rIns="0" bIns="0" rtlCol="0" anchor="t">
+            <a:normAutofit/>
+          </a:bodyPr>
+          <a:lstStyle/>
           <a:p>
             <a:pPr algn="l" indent="0" marL="0">
               <a:buNone/>
             </a:pPr>
             <a:r>
-              <a:rPr lang="en-US" sz="1300" b="1" dirty="0">
-                <a:solidFill>
-                  <a:srgbClr val="0B1F3A"/>
-                </a:solidFill>
-                <a:latin typeface="Aptos" pitchFamily="34" charset="0"/>
-                <a:ea typeface="Aptos" pitchFamily="34" charset="-122"/>
-                <a:cs typeface="Aptos" pitchFamily="34" charset="-120"/>
-              </a:rPr>
-              <a:t>Practical constraint</a:t>
-            </a:r>
-            <a:endParaRPr lang="en-US" sz="1300" dirty="0"/>
-          </a:p>
-        </p:txBody>
-      </p:sp>
-      <p:sp>
-        <p:nvSpPr>
-          <p:cNvPr id="15" name="Text 13"/>
-          <p:cNvSpPr/>
-          <p:nvPr/>
-        </p:nvSpPr>
-        <p:spPr>
-          <a:xfrm>
-            <a:off x="3227832" y="3099816"/>
-            <a:ext cx="3703320" cy="420624"/>
-          </a:xfrm>
-          <a:prstGeom prst="rect">
-            <a:avLst/>
-          </a:prstGeom>
-          <a:noFill/>
-          <a:ln/>
-        </p:spPr>
-        <p:txBody>
-          <a:bodyPr wrap="square" lIns="0" tIns="0" rIns="0" bIns="0" rtlCol="0" anchor="t">
-            <a:normAutofit/>
-          </a:bodyPr>
-          <a:lstStyle/>
-          <a:p>
-            <a:pPr algn="l" indent="0" marL="0">
-              <a:buNone/>
-            </a:pPr>
-            <a:r>
-              <a:rPr sz="1100">
-                <a:solidFill>
-                  <a:srgbClr val="5D6B7E"/>
+              <a:rPr sz="1100" b="1">
+                <a:solidFill>
+                  <a:srgbClr val="0F172A"/>
                 </a:solidFill>
                 <a:latin typeface="Arial"/>
               </a:rPr>
-              <a:t>DSRC / C-V2X 5.9 GHz channels experience packet collision, transmission latency, and interference as vehicle density escalates under periodic 10 Hz broadcast.</a:t>
+              <a:t>Wireless Channel Saturation</a:t>
             </a:r>
             <a:endParaRPr lang="en-US" sz="1100" dirty="0"/>
+          </a:p>
+          <a:p>
+            <a:pPr algn="l"/>
+            <a:r>
+              <a:rPr sz="950" b="0">
+                <a:solidFill>
+                  <a:srgbClr val="334155"/>
+                </a:solidFill>
+                <a:latin typeface="Arial"/>
+              </a:rPr>
+              <a:t>Standard 10 Hz periodic V2V beaconing saturates 5.9 GHz DSRC / C-V2X channels during dense platooning, causing packet collision &amp; latency.</a:t>
+            </a:r>
           </a:p>
         </p:txBody>
       </p:sp>
@@ -13572,61 +14261,57 @@
             <a:normAutofit/>
           </a:bodyPr>
           <a:lstStyle/>
+          <a:p/>
+        </p:txBody>
+      </p:sp>
+      <p:sp>
+        <p:nvSpPr>
+          <p:cNvPr id="20" name="Text 18"/>
+          <p:cNvSpPr/>
+          <p:nvPr/>
+        </p:nvSpPr>
+        <p:spPr>
+          <a:xfrm>
+            <a:off x="1335024" y="4169664"/>
+            <a:ext cx="5577840" cy="420624"/>
+          </a:xfrm>
+          <a:prstGeom prst="rect">
+            <a:avLst/>
+          </a:prstGeom>
+          <a:noFill/>
+          <a:ln/>
+        </p:spPr>
+        <p:txBody>
+          <a:bodyPr wrap="square" lIns="0" tIns="0" rIns="0" bIns="0" rtlCol="0" anchor="t">
+            <a:normAutofit/>
+          </a:bodyPr>
+          <a:lstStyle/>
           <a:p>
             <a:pPr algn="l" indent="0" marL="0">
               <a:buNone/>
             </a:pPr>
             <a:r>
-              <a:rPr lang="en-US" sz="1300" b="1" dirty="0">
-                <a:solidFill>
-                  <a:srgbClr val="0B1F3A"/>
-                </a:solidFill>
-                <a:latin typeface="Aptos" pitchFamily="34" charset="0"/>
-                <a:ea typeface="Aptos" pitchFamily="34" charset="-122"/>
-                <a:cs typeface="Aptos" pitchFamily="34" charset="-120"/>
-              </a:rPr>
-              <a:t>User / system impact</a:t>
-            </a:r>
-            <a:endParaRPr lang="en-US" sz="1300" dirty="0"/>
-          </a:p>
-        </p:txBody>
-      </p:sp>
-      <p:sp>
-        <p:nvSpPr>
-          <p:cNvPr id="20" name="Text 18"/>
-          <p:cNvSpPr/>
-          <p:nvPr/>
-        </p:nvSpPr>
-        <p:spPr>
-          <a:xfrm>
-            <a:off x="3227832" y="4169664"/>
-            <a:ext cx="3703320" cy="420624"/>
-          </a:xfrm>
-          <a:prstGeom prst="rect">
-            <a:avLst/>
-          </a:prstGeom>
-          <a:noFill/>
-          <a:ln/>
-        </p:spPr>
-        <p:txBody>
-          <a:bodyPr wrap="square" lIns="0" tIns="0" rIns="0" bIns="0" rtlCol="0" anchor="t">
-            <a:normAutofit/>
-          </a:bodyPr>
-          <a:lstStyle/>
-          <a:p>
-            <a:pPr algn="l" indent="0" marL="0">
-              <a:buNone/>
-            </a:pPr>
-            <a:r>
-              <a:rPr sz="1100">
-                <a:solidFill>
-                  <a:srgbClr val="5D6B7E"/>
+              <a:rPr sz="1100" b="1">
+                <a:solidFill>
+                  <a:srgbClr val="0F172A"/>
                 </a:solidFill>
                 <a:latin typeface="Arial"/>
               </a:rPr>
-              <a:t>Commuters face stop-and-go delays and elevated collision risks; better coordination aims to smooth speed changes and improve merge safety.</a:t>
+              <a:t>Safety vs Efficiency Dilemma</a:t>
             </a:r>
             <a:endParaRPr lang="en-US" sz="1100" dirty="0"/>
+          </a:p>
+          <a:p>
+            <a:pPr algn="l"/>
+            <a:r>
+              <a:rPr sz="950" b="0">
+                <a:solidFill>
+                  <a:srgbClr val="334155"/>
+                </a:solidFill>
+                <a:latin typeface="Arial"/>
+              </a:rPr>
+              <a:t>Stop-and-go waves increase fuel waste and crash risk; merging controllers must guarantee string stability even under wireless packet drops.</a:t>
+            </a:r>
           </a:p>
         </p:txBody>
       </p:sp>
@@ -13729,13 +14414,13 @@
               <a:buNone/>
             </a:pPr>
             <a:r>
-              <a:rPr sz="1400">
-                <a:solidFill>
-                  <a:srgbClr val="CFE0EF"/>
+              <a:rPr sz="1000" b="0">
+                <a:solidFill>
+                  <a:srgbClr val="334155"/>
                 </a:solidFill>
                 <a:latin typeface="Arial"/>
               </a:rPr>
-              <a:t>With emerging V2X standards (C-V2X Rel-16) and commercial automated vehicle deployment, merging controllers must be bandwidth-frugal and resilient to real packet loss.</a:t>
+              <a:t>As CAV penetration rises, merging controllers cannot rely on infinite wireless bandwidth; algorithms must be bandwidth-frugal and loss-resilient.</a:t>
             </a:r>
             <a:endParaRPr lang="en-US" sz="1400" dirty="0"/>
           </a:p>
@@ -13838,13 +14523,13 @@
               <a:buNone/>
             </a:pPr>
             <a:r>
-              <a:rPr sz="1300" b="1">
-                <a:solidFill>
-                  <a:srgbClr val="FFFFFF"/>
+              <a:rPr sz="1000" b="0">
+                <a:solidFill>
+                  <a:srgbClr val="1565C0"/>
                 </a:solidFill>
                 <a:latin typeface="Arial"/>
               </a:rPr>
-              <a:t>From channel-saturating 10 Hz periodic broadcasting -&gt; to bandwidth-efficient event-triggered communication with dead-reckoning support.</a:t>
+              <a:t>From channel-saturating 10 Hz periodic broadcasting → to bandwidth-efficient event-triggered updates with predictive dead reckoning.</a:t>
             </a:r>
             <a:endParaRPr lang="en-US" sz="1300" dirty="0"/>
           </a:p>
@@ -13889,12 +14574,16 @@
             </a:lvl1pPr>
           </a:lstStyle>
           <a:p>
-            <a:pPr algn="l"/>
-            <a:fld id="{F7021451-1387-4CA6-816F-3879F97B5CBC}" type="slidenum">
-              <a:rPr b="0" lang="en-US"/>
+            <a:pPr>
+              <a:defRPr sz="1000">
+                <a:solidFill>
+                  <a:srgbClr val="94A3B8"/>
+                </a:solidFill>
+              </a:defRPr>
+            </a:pPr>
+            <a:r>
               <a:t>4</a:t>
-            </a:fld>
-            <a:endParaRPr lang="en-US"/>
+            </a:r>
           </a:p>
         </p:txBody>
       </p:sp>
@@ -14747,13 +15436,13 @@
               <a:buNone/>
             </a:pPr>
             <a:r>
-              <a:rPr sz="930">
-                <a:solidFill>
-                  <a:srgbClr val="1E293B"/>
+              <a:rPr sz="950" b="0">
+                <a:solidFill>
+                  <a:srgbClr val="334155"/>
                 </a:solidFill>
                 <a:latin typeface="Arial"/>
               </a:rPr>
-              <a:t>Proposes dynamic merge speed &amp; virtual sequence; assumes ideal 0-loss, 0-delay V2X with no channel optimization</a:t>
+              <a:t>Dynamic speed &amp; virtual slot concept; assumes ideal 0-loss, 0-delay V2X with no channel limits.</a:t>
             </a:r>
             <a:endParaRPr lang="en-US" sz="930" dirty="0"/>
           </a:p>
@@ -15087,13 +15776,13 @@
               <a:buNone/>
             </a:pPr>
             <a:r>
-              <a:rPr sz="930">
-                <a:solidFill>
-                  <a:srgbClr val="1E293B"/>
+              <a:rPr sz="950" b="0">
+                <a:solidFill>
+                  <a:srgbClr val="334155"/>
                 </a:solidFill>
                 <a:latin typeface="Arial"/>
               </a:rPr>
-              <a:t>Demonstrated stable vehicle following in real traffic; limited to single-lane following without ramp merge coordination</a:t>
+              <a:t>Empirical highway following; limited to single-lane platoons without ramp merge coordination.</a:t>
             </a:r>
             <a:endParaRPr lang="en-US" sz="930" dirty="0"/>
           </a:p>
@@ -15427,13 +16116,13 @@
               <a:buNone/>
             </a:pPr>
             <a:r>
-              <a:rPr sz="930">
-                <a:solidFill>
-                  <a:srgbClr val="1E293B"/>
+              <a:rPr sz="950" b="0">
+                <a:solidFill>
+                  <a:srgbClr val="334155"/>
                 </a:solidFill>
                 <a:latin typeface="Arial"/>
               </a:rPr>
-              <a:t>Optimizes individual trajectories; computationally prohibitive (QP) and prone to catastrophic failure if RSU drops</a:t>
+              <a:t>Centralized optimal control; computationally heavy (QP) and vulnerable to single-point RSU drop.</a:t>
             </a:r>
             <a:endParaRPr lang="en-US" sz="930" dirty="0"/>
           </a:p>
@@ -15767,13 +16456,13 @@
               <a:buNone/>
             </a:pPr>
             <a:r>
-              <a:rPr sz="930">
-                <a:solidFill>
-                  <a:srgbClr val="1E293B"/>
+              <a:rPr sz="950" b="0">
+                <a:solidFill>
+                  <a:srgbClr val="334155"/>
                 </a:solidFill>
                 <a:latin typeface="Arial"/>
               </a:rPr>
-              <a:t>Theoretical multi-agent consensus proofs; not adapted for highway ramp geometry, asymmetric speeds, or SUMO physics</a:t>
+              <a:t>Event-triggered consensus proofs; lacks realistic highway geometry, speed asymmetry, or SUMO physics.</a:t>
             </a:r>
             <a:endParaRPr lang="en-US" sz="930" dirty="0"/>
           </a:p>
@@ -15832,57 +16521,43 @@
             <a:normAutofit/>
           </a:bodyPr>
           <a:lstStyle/>
+          <a:p/>
+        </p:txBody>
+      </p:sp>
+      <p:sp>
+        <p:nvSpPr>
+          <p:cNvPr id="58" name="Text 56"/>
+          <p:cNvSpPr/>
+          <p:nvPr/>
+        </p:nvSpPr>
+        <p:spPr>
+          <a:xfrm>
+            <a:off x="868680" y="5376672"/>
+            <a:ext cx="10241280" cy="320040"/>
+          </a:xfrm>
+          <a:prstGeom prst="rect">
+            <a:avLst/>
+          </a:prstGeom>
+          <a:noFill/>
+          <a:ln/>
+        </p:spPr>
+        <p:txBody>
+          <a:bodyPr wrap="square" lIns="0" tIns="0" rIns="0" bIns="0" rtlCol="0" anchor="ctr">
+            <a:normAutofit/>
+          </a:bodyPr>
+          <a:lstStyle/>
           <a:p>
             <a:pPr algn="l" indent="0" marL="0">
               <a:buNone/>
             </a:pPr>
             <a:r>
-              <a:rPr sz="1000" b="1">
-                <a:solidFill>
-                  <a:srgbClr val="13A6A6"/>
+              <a:rPr sz="1050" b="1">
+                <a:solidFill>
+                  <a:srgbClr val="1565C0"/>
                 </a:solidFill>
                 <a:latin typeface="Arial"/>
               </a:rPr>
-              <a:t>Literature Review Takeaway</a:t>
-            </a:r>
-            <a:endParaRPr lang="en-US" sz="1000" dirty="0"/>
-          </a:p>
-        </p:txBody>
-      </p:sp>
-      <p:sp>
-        <p:nvSpPr>
-          <p:cNvPr id="58" name="Text 56"/>
-          <p:cNvSpPr/>
-          <p:nvPr/>
-        </p:nvSpPr>
-        <p:spPr>
-          <a:xfrm>
-            <a:off x="1847088" y="5385816"/>
-            <a:ext cx="9144000" cy="320040"/>
-          </a:xfrm>
-          <a:prstGeom prst="rect">
-            <a:avLst/>
-          </a:prstGeom>
-          <a:noFill/>
-          <a:ln/>
-        </p:spPr>
-        <p:txBody>
-          <a:bodyPr wrap="square" lIns="0" tIns="0" rIns="0" bIns="0" rtlCol="0" anchor="ctr">
-            <a:normAutofit/>
-          </a:bodyPr>
-          <a:lstStyle/>
-          <a:p>
-            <a:pPr algn="l" indent="0" marL="0">
-              <a:buNone/>
-            </a:pPr>
-            <a:r>
-              <a:rPr sz="1250" b="1">
-                <a:solidFill>
-                  <a:srgbClr val="0B1F3A"/>
-                </a:solidFill>
-                <a:latin typeface="Arial"/>
-              </a:rPr>
-              <a:t>Prior works either unrealistically assume perfect wireless channels or suffer severe channel saturation under continuous 10 Hz beaconing during high-density merging.</a:t>
+              <a:t>Key Literature Gap:  Existing works either assume unrealistic zero-loss channels or suffer severe spectrum saturation under continuous 10 Hz broadcasting.</a:t>
             </a:r>
             <a:endParaRPr lang="en-US" sz="1250" dirty="0"/>
           </a:p>
@@ -15927,12 +16602,16 @@
             </a:lvl1pPr>
           </a:lstStyle>
           <a:p>
-            <a:pPr algn="l"/>
-            <a:fld id="{F7021451-1387-4CA6-816F-3879F97B5CBC}" type="slidenum">
-              <a:rPr b="0" lang="en-US"/>
+            <a:pPr>
+              <a:defRPr sz="1000">
+                <a:solidFill>
+                  <a:srgbClr val="94A3B8"/>
+                </a:solidFill>
+              </a:defRPr>
+            </a:pPr>
+            <a:r>
               <a:t>5</a:t>
-            </a:fld>
-            <a:endParaRPr lang="en-US"/>
+            </a:r>
           </a:p>
         </p:txBody>
       </p:sp>
@@ -16241,13 +16920,13 @@
               <a:buNone/>
             </a:pPr>
             <a:r>
-              <a:rPr sz="2000" b="1">
-                <a:solidFill>
-                  <a:srgbClr val="FFFFFF"/>
+              <a:rPr sz="1100" b="0">
+                <a:solidFill>
+                  <a:srgbClr val="0F172A"/>
                 </a:solidFill>
                 <a:latin typeface="Arial"/>
               </a:rPr>
-              <a:t>“Given asymmetric CAV streams on a main highway (25 m/s) and an on-ramp (15 m/s), design a distributed coordination system that dynamically determines a bottleneck merge speed, assigns conflict-free arrival slots, and executes longitudinal consensus control under realistic and bandwidth-constrained wireless channels without physical collisions.”</a:t>
+              <a:t>“Given asymmetric CAV streams on a main highway (25 m/s) and an on-ramp (15 m/s), design a distributed coordination system that dynamically determines a bottleneck merge speed, assigns conflict-free arrival slots, and executes consensus control under bandwidth-constrained and lossy wireless channels without collisions.”</a:t>
             </a:r>
             <a:endParaRPr lang="en-US" sz="2000" dirty="0"/>
           </a:p>
@@ -16280,13 +16959,13 @@
               <a:buNone/>
             </a:pPr>
             <a:r>
-              <a:rPr sz="1150">
-                <a:solidFill>
-                  <a:srgbClr val="B9CBDC"/>
+              <a:rPr sz="1050" b="1">
+                <a:solidFill>
+                  <a:srgbClr val="1565C0"/>
                 </a:solidFill>
                 <a:latin typeface="Arial"/>
               </a:rPr>
-              <a:t>The objective is to minimize V2X communication overhead while maintaining stable vehicle coordination, collision avoidance, and passenger comfort.</a:t>
+              <a:t>Objective: Minimize V2X communication load while guaranteeing string stability, zero collisions, and passenger comfort.</a:t>
             </a:r>
             <a:endParaRPr lang="en-US" sz="1150" dirty="0"/>
           </a:p>
@@ -16757,12 +17436,16 @@
             </a:lvl1pPr>
           </a:lstStyle>
           <a:p>
-            <a:pPr algn="l"/>
-            <a:fld id="{F7021451-1387-4CA6-816F-3879F97B5CBC}" type="slidenum">
-              <a:rPr b="0" lang="en-US"/>
+            <a:pPr>
+              <a:defRPr sz="1000">
+                <a:solidFill>
+                  <a:srgbClr val="94A3B8"/>
+                </a:solidFill>
+              </a:defRPr>
+            </a:pPr>
+            <a:r>
               <a:t>6</a:t>
-            </a:fld>
-            <a:endParaRPr lang="en-US"/>
+            </a:r>
           </a:p>
         </p:txBody>
       </p:sp>
@@ -17094,7 +17777,7 @@
         <p:spPr>
           <a:xfrm>
             <a:off x="868680" y="3127248"/>
-            <a:ext cx="2788920" cy="603504"/>
+            <a:ext cx="3108960" cy="603504"/>
           </a:xfrm>
           <a:prstGeom prst="rect">
             <a:avLst/>
@@ -17112,13 +17795,13 @@
               <a:buNone/>
             </a:pPr>
             <a:r>
-              <a:rPr sz="1150">
-                <a:solidFill>
-                  <a:srgbClr val="5D6B7E"/>
+              <a:rPr sz="1000" b="0">
+                <a:solidFill>
+                  <a:srgbClr val="334155"/>
                 </a:solidFill>
                 <a:latin typeface="Arial"/>
               </a:rPr>
-              <a:t>Several reviewed studies assume ideal or near-ideal communication, leaving realistic wireless impairments such as packet loss and delay jitter less explored.</a:t>
+              <a:t>Ideal Channel Assumption: Prior studies evaluate under perfect wireless links, ignoring bursty loss and transmission delays.</a:t>
             </a:r>
             <a:endParaRPr lang="en-US" sz="1150" dirty="0"/>
           </a:p>
@@ -17146,23 +17829,7 @@
             <a:normAutofit/>
           </a:bodyPr>
           <a:lstStyle/>
-          <a:p>
-            <a:pPr algn="ctr" indent="0" marL="0">
-              <a:buNone/>
-            </a:pPr>
-            <a:r>
-              <a:rPr lang="en-US" sz="1800" b="1" dirty="0">
-                <a:solidFill>
-                  <a:srgbClr val="1D5FA7"/>
-                </a:solidFill>
-                <a:latin typeface="Aptos" pitchFamily="34" charset="0"/>
-                <a:ea typeface="Aptos" pitchFamily="34" charset="-122"/>
-                <a:cs typeface="Aptos" pitchFamily="34" charset="-120"/>
-              </a:rPr>
-              <a:t>→</a:t>
-            </a:r>
-            <a:endParaRPr lang="en-US" sz="1800" dirty="0"/>
-          </a:p>
+          <a:p/>
         </p:txBody>
       </p:sp>
       <p:sp>
@@ -17318,7 +17985,7 @@
         <p:spPr>
           <a:xfrm>
             <a:off x="4498848" y="3127248"/>
-            <a:ext cx="2788920" cy="603504"/>
+            <a:ext cx="3108960" cy="603504"/>
           </a:xfrm>
           <a:prstGeom prst="rect">
             <a:avLst/>
@@ -17336,13 +18003,13 @@
               <a:buNone/>
             </a:pPr>
             <a:r>
-              <a:rPr sz="1150">
-                <a:solidFill>
-                  <a:srgbClr val="5D6B7E"/>
+              <a:rPr sz="1000" b="0">
+                <a:solidFill>
+                  <a:srgbClr val="334155"/>
                 </a:solidFill>
                 <a:latin typeface="Arial"/>
               </a:rPr>
-              <a:t>Standard 10 Hz periodic V2V broadcasting causes channel saturation and packet collision during dense traffic, transmitting redundant state data during steady cruising.</a:t>
+              <a:t>Beacon Saturation: Standard 10 Hz periodic V2V floods the channel with redundant cruising telemetry in dense traffic.</a:t>
             </a:r>
             <a:endParaRPr lang="en-US" sz="1150" dirty="0"/>
           </a:p>
@@ -17370,23 +18037,7 @@
             <a:normAutofit/>
           </a:bodyPr>
           <a:lstStyle/>
-          <a:p>
-            <a:pPr algn="ctr" indent="0" marL="0">
-              <a:buNone/>
-            </a:pPr>
-            <a:r>
-              <a:rPr lang="en-US" sz="1800" b="1" dirty="0">
-                <a:solidFill>
-                  <a:srgbClr val="E46F5F"/>
-                </a:solidFill>
-                <a:latin typeface="Aptos" pitchFamily="34" charset="0"/>
-                <a:ea typeface="Aptos" pitchFamily="34" charset="-122"/>
-                <a:cs typeface="Aptos" pitchFamily="34" charset="-120"/>
-              </a:rPr>
-              <a:t>→</a:t>
-            </a:r>
-            <a:endParaRPr lang="en-US" sz="1800" dirty="0"/>
-          </a:p>
+          <a:p/>
         </p:txBody>
       </p:sp>
       <p:sp>
@@ -17542,7 +18193,7 @@
         <p:spPr>
           <a:xfrm>
             <a:off x="8129016" y="3127248"/>
-            <a:ext cx="2788920" cy="603504"/>
+            <a:ext cx="3108960" cy="603504"/>
           </a:xfrm>
           <a:prstGeom prst="rect">
             <a:avLst/>
@@ -17560,13 +18211,13 @@
               <a:buNone/>
             </a:pPr>
             <a:r>
-              <a:rPr sz="1150">
-                <a:solidFill>
-                  <a:srgbClr val="5D6B7E"/>
+              <a:rPr sz="1000" b="0">
+                <a:solidFill>
+                  <a:srgbClr val="334155"/>
                 </a:solidFill>
                 <a:latin typeface="Arial"/>
               </a:rPr>
-              <a:t>Cooperative controllers often degrade chaotically during wireless blackouts without an independent, radar-based fail-safe to decouple cooperative consensus from emergency braking.</a:t>
+              <a:t>Unprotected Failover: Systems lack autonomous onboard radar fail-safes to prevent crashes when communication blacks out.</a:t>
             </a:r>
             <a:endParaRPr lang="en-US" sz="1150" dirty="0"/>
           </a:p>
@@ -17594,23 +18245,7 @@
             <a:normAutofit/>
           </a:bodyPr>
           <a:lstStyle/>
-          <a:p>
-            <a:pPr algn="ctr" indent="0" marL="0">
-              <a:buNone/>
-            </a:pPr>
-            <a:r>
-              <a:rPr lang="en-US" sz="1800" b="1" dirty="0">
-                <a:solidFill>
-                  <a:srgbClr val="13A6A6"/>
-                </a:solidFill>
-                <a:latin typeface="Aptos" pitchFamily="34" charset="0"/>
-                <a:ea typeface="Aptos" pitchFamily="34" charset="-122"/>
-                <a:cs typeface="Aptos" pitchFamily="34" charset="-120"/>
-              </a:rPr>
-              <a:t>→</a:t>
-            </a:r>
-            <a:endParaRPr lang="en-US" sz="1800" dirty="0"/>
-          </a:p>
+          <a:p/>
         </p:txBody>
       </p:sp>
       <p:sp>
@@ -17666,57 +18301,43 @@
             <a:normAutofit/>
           </a:bodyPr>
           <a:lstStyle/>
+          <a:p/>
+        </p:txBody>
+      </p:sp>
+      <p:sp>
+        <p:nvSpPr>
+          <p:cNvPr id="26" name="Text 24"/>
+          <p:cNvSpPr/>
+          <p:nvPr/>
+        </p:nvSpPr>
+        <p:spPr>
+          <a:xfrm>
+            <a:off x="886968" y="4754880"/>
+            <a:ext cx="10149840" cy="411480"/>
+          </a:xfrm>
+          <a:prstGeom prst="rect">
+            <a:avLst/>
+          </a:prstGeom>
+          <a:noFill/>
+          <a:ln/>
+        </p:spPr>
+        <p:txBody>
+          <a:bodyPr wrap="square" lIns="0" tIns="0" rIns="0" bIns="0" rtlCol="0" anchor="ctr">
+            <a:normAutofit/>
+          </a:bodyPr>
+          <a:lstStyle/>
           <a:p>
             <a:pPr algn="l" indent="0" marL="0">
               <a:buNone/>
             </a:pPr>
             <a:r>
-              <a:rPr sz="1000" b="1">
-                <a:solidFill>
-                  <a:srgbClr val="13A6A6"/>
+              <a:rPr sz="1050" b="1">
+                <a:solidFill>
+                  <a:srgbClr val="1565C0"/>
                 </a:solidFill>
                 <a:latin typeface="Arial"/>
               </a:rPr>
-              <a:t>Our Proposed Contribution</a:t>
-            </a:r>
-            <a:endParaRPr lang="en-US" sz="1000" dirty="0"/>
-          </a:p>
-        </p:txBody>
-      </p:sp>
-      <p:sp>
-        <p:nvSpPr>
-          <p:cNvPr id="26" name="Text 24"/>
-          <p:cNvSpPr/>
-          <p:nvPr/>
-        </p:nvSpPr>
-        <p:spPr>
-          <a:xfrm>
-            <a:off x="1856232" y="4736592"/>
-            <a:ext cx="9180576" cy="411480"/>
-          </a:xfrm>
-          <a:prstGeom prst="rect">
-            <a:avLst/>
-          </a:prstGeom>
-          <a:noFill/>
-          <a:ln/>
-        </p:spPr>
-        <p:txBody>
-          <a:bodyPr wrap="square" lIns="0" tIns="0" rIns="0" bIns="0" rtlCol="0" anchor="ctr">
-            <a:normAutofit/>
-          </a:bodyPr>
-          <a:lstStyle/>
-          <a:p>
-            <a:pPr algn="l" indent="0" marL="0">
-              <a:buNone/>
-            </a:pPr>
-            <a:r>
-              <a:rPr sz="1350" b="1">
-                <a:solidFill>
-                  <a:srgbClr val="0B1F3A"/>
-                </a:solidFill>
-                <a:latin typeface="Arial"/>
-              </a:rPr>
-              <a:t>Our project addresses these gaps with Event-Triggered V2V, Dead-Reckoning state estimation, and a radar-based TTC fail-safe, targeting ~90% lower communication overhead while preserving collision-free operation in tested scenarios.</a:t>
+              <a:t>Our Proposed Solution:  Event-Triggered V2V + Dead Reckoning + Autonomous Radar Fail-Safe, cutting communication overhead by ~90% while guaranteeing zero collisions.</a:t>
             </a:r>
             <a:endParaRPr lang="en-US" sz="1350" dirty="0"/>
           </a:p>
@@ -17761,12 +18382,16 @@
             </a:lvl1pPr>
           </a:lstStyle>
           <a:p>
-            <a:pPr algn="l"/>
-            <a:fld id="{F7021451-1387-4CA6-816F-3879F97B5CBC}" type="slidenum">
-              <a:rPr b="0" lang="en-US"/>
+            <a:pPr>
+              <a:defRPr sz="1000">
+                <a:solidFill>
+                  <a:srgbClr val="94A3B8"/>
+                </a:solidFill>
+              </a:defRPr>
+            </a:pPr>
+            <a:r>
               <a:t>7</a:t>
-            </a:fld>
-            <a:endParaRPr lang="en-US"/>
+            </a:r>
           </a:p>
         </p:txBody>
       </p:sp>
@@ -18194,13 +18819,13 @@
               <a:buNone/>
             </a:pPr>
             <a:r>
-              <a:rPr sz="1070">
-                <a:solidFill>
-                  <a:srgbClr val="5D6B7E"/>
+              <a:rPr sz="1000" b="0">
+                <a:solidFill>
+                  <a:srgbClr val="334155"/>
                 </a:solidFill>
                 <a:latin typeface="Arial"/>
               </a:rPr>
-              <a:t>Kinematic arrival projections, dynamic merge speed estimation (v_m), and headway constraints along the virtual platoon coordinate axis.</a:t>
+              <a:t>Kinematic arrival projections, dynamic merge speed (v_m = 25 m/s), and virtual platoon coordinate mapping.</a:t>
             </a:r>
             <a:endParaRPr lang="en-US" sz="1070" dirty="0"/>
           </a:p>
@@ -18375,13 +19000,13 @@
               <a:buNone/>
             </a:pPr>
             <a:r>
-              <a:rPr sz="1070">
-                <a:solidFill>
-                  <a:srgbClr val="5D6B7E"/>
+              <a:rPr sz="1000" b="0">
+                <a:solidFill>
+                  <a:srgbClr val="334155"/>
                 </a:solidFill>
                 <a:latin typeface="Arial"/>
               </a:rPr>
-              <a:t>Low-frequency RSU virtual sequencing (0.5 Hz) and distributed consensus CACC with event-triggered broadcast criteria and dead-reckoning extrapolation.</a:t>
+              <a:t>Low-frequency RSU slot allocation (0.5 Hz) + distributed event-triggered CACC with dead reckoning.</a:t>
             </a:r>
             <a:endParaRPr lang="en-US" sz="1070" dirty="0"/>
           </a:p>
@@ -18556,13 +19181,13 @@
               <a:buNone/>
             </a:pPr>
             <a:r>
-              <a:rPr sz="1070">
-                <a:solidFill>
-                  <a:srgbClr val="5D6B7E"/>
+              <a:rPr sz="1000" b="0">
+                <a:solidFill>
+                  <a:srgbClr val="334155"/>
                 </a:solidFill>
                 <a:latin typeface="Arial"/>
               </a:rPr>
-              <a:t>Microscopic co-simulations in Eclipse SUMO/TraCI evaluating safety, throughput, packet volume, and latency across baseline and event-based configurations.</a:t>
+              <a:t>SUMO/TraCI microscopic simulations evaluating throughput, communication overhead, and string stability.</a:t>
             </a:r>
             <a:endParaRPr lang="en-US" sz="1070" dirty="0"/>
           </a:p>
@@ -18737,13 +19362,13 @@
               <a:buNone/>
             </a:pPr>
             <a:r>
-              <a:rPr sz="1070">
-                <a:solidFill>
-                  <a:srgbClr val="5D6B7E"/>
+              <a:rPr sz="1000" b="0">
+                <a:solidFill>
+                  <a:srgbClr val="334155"/>
                 </a:solidFill>
                 <a:latin typeface="Arial"/>
               </a:rPr>
-              <a:t>Empirically assess resilience against channel packet loss (0%, 10%, 30%) and validate autonomous radar fail-safe intervention mechanisms.</a:t>
+              <a:t>Empirical packet loss benchmarks (0%, 10%, 30%) and autonomous radar fail-safe validation.</a:t>
             </a:r>
             <a:endParaRPr lang="en-US" sz="1070" dirty="0"/>
           </a:p>
@@ -18802,57 +19427,43 @@
             <a:normAutofit/>
           </a:bodyPr>
           <a:lstStyle/>
+          <a:p/>
+        </p:txBody>
+      </p:sp>
+      <p:sp>
+        <p:nvSpPr>
+          <p:cNvPr id="30" name="Text 28"/>
+          <p:cNvSpPr/>
+          <p:nvPr/>
+        </p:nvSpPr>
+        <p:spPr>
+          <a:xfrm>
+            <a:off x="877824" y="4709160"/>
+            <a:ext cx="4206240" cy="502920"/>
+          </a:xfrm>
+          <a:prstGeom prst="rect">
+            <a:avLst/>
+          </a:prstGeom>
+          <a:noFill/>
+          <a:ln/>
+        </p:spPr>
+        <p:txBody>
+          <a:bodyPr wrap="square" lIns="0" tIns="0" rIns="0" bIns="0" rtlCol="0" anchor="ctr">
+            <a:normAutofit/>
+          </a:bodyPr>
+          <a:lstStyle/>
           <a:p>
             <a:pPr algn="l" indent="0" marL="0">
               <a:buNone/>
             </a:pPr>
             <a:r>
-              <a:rPr sz="1000" b="1">
-                <a:solidFill>
-                  <a:srgbClr val="13A6A6"/>
+              <a:rPr sz="1050" b="1">
+                <a:solidFill>
+                  <a:srgbClr val="1565C0"/>
                 </a:solidFill>
                 <a:latin typeface="Arial"/>
               </a:rPr>
-              <a:t>Target Success Criteria</a:t>
-            </a:r>
-            <a:endParaRPr lang="en-US" sz="1000" dirty="0"/>
-          </a:p>
-        </p:txBody>
-      </p:sp>
-      <p:sp>
-        <p:nvSpPr>
-          <p:cNvPr id="30" name="Text 28"/>
-          <p:cNvSpPr/>
-          <p:nvPr/>
-        </p:nvSpPr>
-        <p:spPr>
-          <a:xfrm>
-            <a:off x="2029968" y="4663440"/>
-            <a:ext cx="3063240" cy="502920"/>
-          </a:xfrm>
-          <a:prstGeom prst="rect">
-            <a:avLst/>
-          </a:prstGeom>
-          <a:noFill/>
-          <a:ln/>
-        </p:spPr>
-        <p:txBody>
-          <a:bodyPr wrap="square" lIns="0" tIns="0" rIns="0" bIns="0" rtlCol="0" anchor="ctr">
-            <a:normAutofit/>
-          </a:bodyPr>
-          <a:lstStyle/>
-          <a:p>
-            <a:pPr algn="l" indent="0" marL="0">
-              <a:buNone/>
-            </a:pPr>
-            <a:r>
-              <a:rPr sz="1150" b="1">
-                <a:solidFill>
-                  <a:srgbClr val="0B1F3A"/>
-                </a:solidFill>
-                <a:latin typeface="Arial"/>
-              </a:rPr>
-              <a:t>Zero physical collisions across all scenarios, ≥ 80% reduction in V2V packet transmissions, and stable headway convergence under both perfect and lossy channels.</a:t>
+              <a:t>Target Success Criteria:  Zero collisions across all runs, ≥ 80% reduction in V2V packets, and stable headway convergence under both perfect and lossy channels.</a:t>
             </a:r>
             <a:endParaRPr lang="en-US" sz="1150" dirty="0"/>
           </a:p>
@@ -18897,12 +19508,16 @@
             </a:lvl1pPr>
           </a:lstStyle>
           <a:p>
-            <a:pPr algn="l"/>
-            <a:fld id="{F7021451-1387-4CA6-816F-3879F97B5CBC}" type="slidenum">
-              <a:rPr b="0" lang="en-US"/>
+            <a:pPr>
+              <a:defRPr sz="1000">
+                <a:solidFill>
+                  <a:srgbClr val="94A3B8"/>
+                </a:solidFill>
+              </a:defRPr>
+            </a:pPr>
+            <a:r>
               <a:t>8</a:t>
-            </a:fld>
-            <a:endParaRPr lang="en-US"/>
+            </a:r>
           </a:p>
         </p:txBody>
       </p:sp>
@@ -19083,18 +19698,174 @@
       </p:sp>
       <p:sp>
         <p:nvSpPr>
-          <p:cNvPr id="6" name="Shape 4"/>
-          <p:cNvSpPr/>
-          <p:nvPr/>
-        </p:nvSpPr>
-        <p:spPr>
-          <a:xfrm>
-            <a:off x="530352" y="2139696"/>
-            <a:ext cx="1737360" cy="1371600"/>
+          <p:cNvPr id="46" name="Shape 44"/>
+          <p:cNvSpPr/>
+          <p:nvPr/>
+        </p:nvSpPr>
+        <p:spPr>
+          <a:xfrm>
+            <a:off x="658368" y="4041648"/>
+            <a:ext cx="6583680" cy="1417320"/>
           </a:xfrm>
           <a:prstGeom prst="roundRect">
             <a:avLst>
-              <a:gd name="adj" fmla="val 10667"/>
+              <a:gd name="adj" fmla="val 10323"/>
+            </a:avLst>
+          </a:prstGeom>
+          <a:solidFill>
+            <a:srgbClr val="0B1F3A"/>
+          </a:solidFill>
+          <a:ln w="12700">
+            <a:solidFill>
+              <a:srgbClr val="0B1F3A"/>
+            </a:solidFill>
+            <a:prstDash val="solid"/>
+          </a:ln>
+        </p:spPr>
+        <p:txBody>
+          <a:bodyPr/>
+          <a:p/>
+        </p:txBody>
+      </p:sp>
+      <p:sp>
+        <p:nvSpPr>
+          <p:cNvPr id="47" name="Text 45"/>
+          <p:cNvSpPr/>
+          <p:nvPr/>
+        </p:nvSpPr>
+        <p:spPr>
+          <a:xfrm>
+            <a:off x="896112" y="4315968"/>
+            <a:ext cx="1234440" cy="201168"/>
+          </a:xfrm>
+          <a:prstGeom prst="rect">
+            <a:avLst/>
+          </a:prstGeom>
+          <a:noFill/>
+          <a:ln/>
+        </p:spPr>
+        <p:txBody>
+          <a:bodyPr wrap="square" lIns="0" tIns="0" rIns="0" bIns="0" rtlCol="0" anchor="ctr">
+            <a:normAutofit/>
+          </a:bodyPr>
+          <a:lstStyle/>
+          <a:p/>
+        </p:txBody>
+      </p:sp>
+      <p:sp>
+        <p:nvSpPr>
+          <p:cNvPr id="48" name="Text 46"/>
+          <p:cNvSpPr/>
+          <p:nvPr/>
+        </p:nvSpPr>
+        <p:spPr>
+          <a:xfrm>
+            <a:off x="896112" y="4251960"/>
+            <a:ext cx="5120640" cy="1371600"/>
+          </a:xfrm>
+          <a:prstGeom prst="rect">
+            <a:avLst/>
+          </a:prstGeom>
+          <a:noFill/>
+          <a:ln/>
+        </p:spPr>
+        <p:txBody>
+          <a:bodyPr wrap="square" lIns="0" tIns="0" rIns="0" bIns="0" rtlCol="0" anchor="ctr">
+            <a:normAutofit/>
+          </a:bodyPr>
+          <a:lstStyle/>
+          <a:p>
+            <a:pPr algn="l" indent="0" marL="0">
+              <a:buNone/>
+            </a:pPr>
+            <a:r>
+              <a:rPr sz="1100" b="1">
+                <a:solidFill>
+                  <a:srgbClr val="0F172A"/>
+                </a:solidFill>
+                <a:latin typeface="Arial"/>
+              </a:rPr>
+              <a:t>Macro-Coordination: 0.5 Hz RSU Slot Allocation</a:t>
+            </a:r>
+            <a:endParaRPr lang="en-US" sz="1700" dirty="0"/>
+          </a:p>
+          <a:p>
+            <a:pPr algn="l"/>
+            <a:r>
+              <a:rPr sz="950" b="0">
+                <a:solidFill>
+                  <a:srgbClr val="334155"/>
+                </a:solidFill>
+                <a:latin typeface="Arial"/>
+              </a:rPr>
+              <a:t>• RSU detects vehicles at 368 m detection threshold and estimates dynamic bottleneck speed v_m = 25 m/s.</a:t>
+            </a:r>
+          </a:p>
+          <a:p>
+            <a:pPr algn="l"/>
+            <a:r>
+              <a:rPr sz="950" b="0">
+                <a:solidFill>
+                  <a:srgbClr val="334155"/>
+                </a:solidFill>
+                <a:latin typeface="Arial"/>
+              </a:rPr>
+              <a:t>• Calculates kinematic ETA and assigns conflict-free virtual FIFO sequence with 1.5 s time headway.</a:t>
+            </a:r>
+          </a:p>
+          <a:p>
+            <a:pPr algn="l"/>
+            <a:r>
+              <a:rPr sz="950" b="0">
+                <a:solidFill>
+                  <a:srgbClr val="334155"/>
+                </a:solidFill>
+                <a:latin typeface="Arial"/>
+              </a:rPr>
+              <a:t>• Infrequent 0.5 Hz downlink preserves infrastructure bandwidth.</a:t>
+            </a:r>
+          </a:p>
+        </p:txBody>
+      </p:sp>
+      <p:sp>
+        <p:nvSpPr>
+          <p:cNvPr id="49" name="Text 47"/>
+          <p:cNvSpPr/>
+          <p:nvPr/>
+        </p:nvSpPr>
+        <p:spPr>
+          <a:xfrm>
+            <a:off x="2084832" y="4690872"/>
+            <a:ext cx="4617720" cy="411480"/>
+          </a:xfrm>
+          <a:prstGeom prst="rect">
+            <a:avLst/>
+          </a:prstGeom>
+          <a:noFill/>
+          <a:ln/>
+        </p:spPr>
+        <p:txBody>
+          <a:bodyPr wrap="square" lIns="0" tIns="0" rIns="0" bIns="0" rtlCol="0" anchor="ctr">
+            <a:normAutofit/>
+          </a:bodyPr>
+          <a:lstStyle/>
+          <a:p/>
+        </p:txBody>
+      </p:sp>
+      <p:sp>
+        <p:nvSpPr>
+          <p:cNvPr id="50" name="Shape 48"/>
+          <p:cNvSpPr/>
+          <p:nvPr/>
+        </p:nvSpPr>
+        <p:spPr>
+          <a:xfrm>
+            <a:off x="7516368" y="4041648"/>
+            <a:ext cx="3895344" cy="1417320"/>
+          </a:xfrm>
+          <a:prstGeom prst="roundRect">
+            <a:avLst>
+              <a:gd name="adj" fmla="val 10323"/>
             </a:avLst>
           </a:prstGeom>
           <a:solidFill>
@@ -19114,1564 +19885,88 @@
       </p:sp>
       <p:sp>
         <p:nvSpPr>
-          <p:cNvPr id="7" name="Shape 5"/>
-          <p:cNvSpPr/>
-          <p:nvPr/>
-        </p:nvSpPr>
-        <p:spPr>
-          <a:xfrm>
-            <a:off x="676656" y="2313432"/>
-            <a:ext cx="384048" cy="310896"/>
-          </a:xfrm>
-          <a:prstGeom prst="roundRect">
-            <a:avLst>
-              <a:gd name="adj" fmla="val 50000"/>
-            </a:avLst>
-          </a:prstGeom>
-          <a:solidFill>
-            <a:srgbClr val="0B1F3A"/>
-          </a:solidFill>
-          <a:ln w="12700">
-            <a:solidFill>
-              <a:srgbClr val="0B1F3A"/>
-            </a:solidFill>
-            <a:prstDash val="solid"/>
-          </a:ln>
-        </p:spPr>
-        <p:txBody>
-          <a:bodyPr/>
-          <a:p/>
-        </p:txBody>
-      </p:sp>
-      <p:sp>
-        <p:nvSpPr>
-          <p:cNvPr id="8" name="Text 6"/>
-          <p:cNvSpPr/>
-          <p:nvPr/>
-        </p:nvSpPr>
-        <p:spPr>
-          <a:xfrm>
-            <a:off x="749808" y="2331720"/>
-            <a:ext cx="237744" cy="228600"/>
-          </a:xfrm>
-          <a:prstGeom prst="rect">
-            <a:avLst/>
-          </a:prstGeom>
-          <a:noFill/>
-          <a:ln/>
-        </p:spPr>
-        <p:txBody>
-          <a:bodyPr wrap="square" lIns="0" tIns="0" rIns="0" bIns="0" rtlCol="0" anchor="ctr">
-            <a:normAutofit/>
-          </a:bodyPr>
-          <a:lstStyle/>
-          <a:p>
-            <a:pPr algn="ctr" indent="0" marL="0">
-              <a:buNone/>
-            </a:pPr>
-            <a:r>
-              <a:rPr lang="en-US" sz="950" b="1" dirty="0">
-                <a:solidFill>
-                  <a:srgbClr val="FFFFFF"/>
-                </a:solidFill>
-                <a:latin typeface="Aptos" pitchFamily="34" charset="0"/>
-                <a:ea typeface="Aptos" pitchFamily="34" charset="-122"/>
-                <a:cs typeface="Aptos" pitchFamily="34" charset="-120"/>
-              </a:rPr>
-              <a:t>01</a:t>
-            </a:r>
-            <a:endParaRPr lang="en-US" sz="950" dirty="0"/>
-          </a:p>
-        </p:txBody>
-      </p:sp>
-      <p:sp>
-        <p:nvSpPr>
-          <p:cNvPr id="9" name="Text 7"/>
-          <p:cNvSpPr/>
-          <p:nvPr/>
-        </p:nvSpPr>
-        <p:spPr>
-          <a:xfrm>
-            <a:off x="676656" y="2743200"/>
-            <a:ext cx="1444752" cy="219456"/>
-          </a:xfrm>
-          <a:prstGeom prst="rect">
-            <a:avLst/>
-          </a:prstGeom>
-          <a:noFill/>
-          <a:ln/>
-        </p:spPr>
-        <p:txBody>
-          <a:bodyPr wrap="square" lIns="0" tIns="0" rIns="0" bIns="0" rtlCol="0" anchor="ctr">
-            <a:normAutofit/>
-          </a:bodyPr>
-          <a:lstStyle/>
-          <a:p>
-            <a:pPr algn="ctr" indent="0" marL="0">
-              <a:buNone/>
-            </a:pPr>
-            <a:r>
-              <a:rPr sz="1250" b="1">
-                <a:solidFill>
-                  <a:srgbClr val="0B1F3A"/>
+          <p:cNvPr id="51" name="Text 49"/>
+          <p:cNvSpPr/>
+          <p:nvPr/>
+        </p:nvSpPr>
+        <p:spPr>
+          <a:xfrm>
+            <a:off x="6217920" y="4251960"/>
+            <a:ext cx="5120640" cy="1371600"/>
+          </a:xfrm>
+          <a:prstGeom prst="rect">
+            <a:avLst/>
+          </a:prstGeom>
+          <a:noFill/>
+          <a:ln/>
+        </p:spPr>
+        <p:txBody>
+          <a:bodyPr wrap="square" lIns="0" tIns="0" rIns="0" bIns="0" rtlCol="0" anchor="ctr">
+            <a:normAutofit/>
+          </a:bodyPr>
+          <a:lstStyle/>
+          <a:p>
+            <a:pPr algn="l" indent="0" marL="0">
+              <a:buNone/>
+            </a:pPr>
+            <a:r>
+              <a:rPr sz="1100" b="1">
+                <a:solidFill>
+                  <a:srgbClr val="0F172A"/>
                 </a:solidFill>
                 <a:latin typeface="Arial"/>
               </a:rPr>
-              <a:t>V2I Ingestion</a:t>
-            </a:r>
-            <a:endParaRPr lang="en-US" sz="1250" dirty="0"/>
-          </a:p>
-        </p:txBody>
-      </p:sp>
-      <p:sp>
-        <p:nvSpPr>
-          <p:cNvPr id="10" name="Text 8"/>
-          <p:cNvSpPr/>
-          <p:nvPr/>
-        </p:nvSpPr>
-        <p:spPr>
-          <a:xfrm>
-            <a:off x="676656" y="3081528"/>
-            <a:ext cx="1444752" cy="274320"/>
-          </a:xfrm>
-          <a:prstGeom prst="rect">
-            <a:avLst/>
-          </a:prstGeom>
-          <a:noFill/>
-          <a:ln/>
-        </p:spPr>
-        <p:txBody>
-          <a:bodyPr wrap="square" lIns="0" tIns="0" rIns="0" bIns="0" rtlCol="0" anchor="ctr">
-            <a:normAutofit/>
-          </a:bodyPr>
-          <a:lstStyle/>
-          <a:p>
-            <a:pPr algn="ctr" indent="0" marL="0">
-              <a:buNone/>
-            </a:pPr>
-            <a:r>
-              <a:rPr sz="930">
-                <a:solidFill>
-                  <a:srgbClr val="5D6B7E"/>
+              <a:t>Micro-Execution: 10 Hz Distributed CACC &amp; Fail-Safe</a:t>
+            </a:r>
+            <a:endParaRPr lang="en-US" sz="1000" dirty="0"/>
+          </a:p>
+          <a:p>
+            <a:pPr algn="l"/>
+            <a:r>
+              <a:rPr sz="950" b="0">
+                <a:solidFill>
+                  <a:srgbClr val="334155"/>
                 </a:solidFill>
                 <a:latin typeface="Arial"/>
               </a:rPr>
-              <a:t>Entry detection at 368m; report speed &amp; distance</a:t>
-            </a:r>
-            <a:endParaRPr lang="en-US" sz="930" dirty="0"/>
-          </a:p>
-        </p:txBody>
-      </p:sp>
-      <p:sp>
-        <p:nvSpPr>
-          <p:cNvPr id="11" name="Shape 9"/>
-          <p:cNvSpPr/>
-          <p:nvPr/>
-        </p:nvSpPr>
-        <p:spPr>
-          <a:xfrm>
-            <a:off x="2267712" y="2816352"/>
-            <a:ext cx="146304" cy="0"/>
-          </a:xfrm>
-          <a:prstGeom prst="line">
-            <a:avLst/>
-          </a:prstGeom>
-          <a:noFill/>
-          <a:ln w="12700">
-            <a:solidFill>
-              <a:srgbClr val="13A6A6"/>
-            </a:solidFill>
-            <a:prstDash val="solid"/>
-            <a:headEnd type="none"/>
-            <a:tailEnd type="none"/>
-          </a:ln>
-        </p:spPr>
-        <p:txBody>
-          <a:bodyPr/>
-          <a:p/>
-        </p:txBody>
-      </p:sp>
-      <p:sp>
-        <p:nvSpPr>
-          <p:cNvPr id="12" name="Shape 10"/>
-          <p:cNvSpPr/>
-          <p:nvPr/>
-        </p:nvSpPr>
-        <p:spPr>
-          <a:xfrm>
-            <a:off x="2340864" y="2734056"/>
-            <a:ext cx="137160" cy="164592"/>
-          </a:xfrm>
-          <a:prstGeom prst="chevron">
-            <a:avLst/>
-          </a:prstGeom>
-          <a:solidFill>
-            <a:srgbClr val="13A6A6"/>
-          </a:solidFill>
-          <a:ln w="12700">
-            <a:solidFill>
-              <a:srgbClr val="13A6A6"/>
-            </a:solidFill>
-            <a:prstDash val="solid"/>
-          </a:ln>
-        </p:spPr>
-        <p:txBody>
-          <a:bodyPr/>
-          <a:p/>
-        </p:txBody>
-      </p:sp>
-      <p:sp>
-        <p:nvSpPr>
-          <p:cNvPr id="13" name="Shape 11"/>
-          <p:cNvSpPr/>
-          <p:nvPr/>
-        </p:nvSpPr>
-        <p:spPr>
-          <a:xfrm>
-            <a:off x="2404872" y="2139696"/>
-            <a:ext cx="1737360" cy="1371600"/>
-          </a:xfrm>
-          <a:prstGeom prst="roundRect">
-            <a:avLst>
-              <a:gd name="adj" fmla="val 10667"/>
-            </a:avLst>
-          </a:prstGeom>
-          <a:solidFill>
-            <a:srgbClr val="FFFFFF"/>
-          </a:solidFill>
-          <a:ln w="12700">
-            <a:solidFill>
-              <a:srgbClr val="D8DEE8"/>
-            </a:solidFill>
-            <a:prstDash val="solid"/>
-          </a:ln>
-        </p:spPr>
-        <p:txBody>
-          <a:bodyPr/>
-          <a:p/>
-        </p:txBody>
-      </p:sp>
-      <p:sp>
-        <p:nvSpPr>
-          <p:cNvPr id="14" name="Shape 12"/>
-          <p:cNvSpPr/>
-          <p:nvPr/>
-        </p:nvSpPr>
-        <p:spPr>
-          <a:xfrm>
-            <a:off x="2551176" y="2313432"/>
-            <a:ext cx="384048" cy="310896"/>
-          </a:xfrm>
-          <a:prstGeom prst="roundRect">
-            <a:avLst>
-              <a:gd name="adj" fmla="val 50000"/>
-            </a:avLst>
-          </a:prstGeom>
-          <a:solidFill>
-            <a:srgbClr val="0B1F3A"/>
-          </a:solidFill>
-          <a:ln w="12700">
-            <a:solidFill>
-              <a:srgbClr val="0B1F3A"/>
-            </a:solidFill>
-            <a:prstDash val="solid"/>
-          </a:ln>
-        </p:spPr>
-        <p:txBody>
-          <a:bodyPr/>
-          <a:p/>
-        </p:txBody>
-      </p:sp>
-      <p:sp>
-        <p:nvSpPr>
-          <p:cNvPr id="15" name="Text 13"/>
-          <p:cNvSpPr/>
-          <p:nvPr/>
-        </p:nvSpPr>
-        <p:spPr>
-          <a:xfrm>
-            <a:off x="2624328" y="2331720"/>
-            <a:ext cx="237744" cy="228600"/>
-          </a:xfrm>
-          <a:prstGeom prst="rect">
-            <a:avLst/>
-          </a:prstGeom>
-          <a:noFill/>
-          <a:ln/>
-        </p:spPr>
-        <p:txBody>
-          <a:bodyPr wrap="square" lIns="0" tIns="0" rIns="0" bIns="0" rtlCol="0" anchor="ctr">
-            <a:normAutofit/>
-          </a:bodyPr>
-          <a:lstStyle/>
-          <a:p>
-            <a:pPr algn="ctr" indent="0" marL="0">
-              <a:buNone/>
-            </a:pPr>
-            <a:r>
-              <a:rPr lang="en-US" sz="950" b="1" dirty="0">
-                <a:solidFill>
-                  <a:srgbClr val="FFFFFF"/>
-                </a:solidFill>
-                <a:latin typeface="Aptos" pitchFamily="34" charset="0"/>
-                <a:ea typeface="Aptos" pitchFamily="34" charset="-122"/>
-                <a:cs typeface="Aptos" pitchFamily="34" charset="-120"/>
-              </a:rPr>
-              <a:t>02</a:t>
-            </a:r>
-            <a:endParaRPr lang="en-US" sz="950" dirty="0"/>
-          </a:p>
-        </p:txBody>
-      </p:sp>
-      <p:sp>
-        <p:nvSpPr>
-          <p:cNvPr id="16" name="Text 14"/>
-          <p:cNvSpPr/>
-          <p:nvPr/>
-        </p:nvSpPr>
-        <p:spPr>
-          <a:xfrm>
-            <a:off x="2551176" y="2743200"/>
-            <a:ext cx="1444752" cy="219456"/>
-          </a:xfrm>
-          <a:prstGeom prst="rect">
-            <a:avLst/>
-          </a:prstGeom>
-          <a:noFill/>
-          <a:ln/>
-        </p:spPr>
-        <p:txBody>
-          <a:bodyPr wrap="square" lIns="0" tIns="0" rIns="0" bIns="0" rtlCol="0" anchor="ctr">
-            <a:normAutofit/>
-          </a:bodyPr>
-          <a:lstStyle/>
-          <a:p>
-            <a:pPr algn="ctr" indent="0" marL="0">
-              <a:buNone/>
-            </a:pPr>
-            <a:r>
-              <a:rPr sz="1250" b="1">
-                <a:solidFill>
-                  <a:srgbClr val="0B1F3A"/>
+              <a:t>• Consensus Law: a = -kp*(d_des - gap_ghost) - kv*(v - v_pred) with comfort bounds [-3.0, +2.0] m/s².</a:t>
+            </a:r>
+          </a:p>
+          <a:p>
+            <a:pPr algn="l"/>
+            <a:r>
+              <a:rPr sz="950" b="0">
+                <a:solidFill>
+                  <a:srgbClr val="334155"/>
                 </a:solidFill>
                 <a:latin typeface="Arial"/>
               </a:rPr>
-              <a:t>Bottleneck Speed</a:t>
-            </a:r>
-            <a:endParaRPr lang="en-US" sz="1250" dirty="0"/>
-          </a:p>
-        </p:txBody>
-      </p:sp>
-      <p:sp>
-        <p:nvSpPr>
-          <p:cNvPr id="17" name="Text 15"/>
-          <p:cNvSpPr/>
-          <p:nvPr/>
-        </p:nvSpPr>
-        <p:spPr>
-          <a:xfrm>
-            <a:off x="2551176" y="3081528"/>
-            <a:ext cx="1444752" cy="274320"/>
-          </a:xfrm>
-          <a:prstGeom prst="rect">
-            <a:avLst/>
-          </a:prstGeom>
-          <a:noFill/>
-          <a:ln/>
-        </p:spPr>
-        <p:txBody>
-          <a:bodyPr wrap="square" lIns="0" tIns="0" rIns="0" bIns="0" rtlCol="0" anchor="ctr">
-            <a:normAutofit/>
-          </a:bodyPr>
-          <a:lstStyle/>
-          <a:p>
-            <a:pPr algn="ctr" indent="0" marL="0">
-              <a:buNone/>
-            </a:pPr>
-            <a:r>
-              <a:rPr sz="930">
-                <a:solidFill>
-                  <a:srgbClr val="5D6B7E"/>
+              <a:t>• Event-Trigger: Broadcasts only on Δv ≥ 0.3 m/s, Δd ≥ 0.5 m, or 1.0 s heartbeat (suppresses ~90% packets).</a:t>
+            </a:r>
+          </a:p>
+          <a:p>
+            <a:pPr algn="l"/>
+            <a:r>
+              <a:rPr sz="950" b="0">
+                <a:solidFill>
+                  <a:srgbClr val="334155"/>
                 </a:solidFill>
                 <a:latin typeface="Arial"/>
               </a:rPr>
-              <a:t>Compute dynamic merge velocity v_m from vehicle arrival states</a:t>
-            </a:r>
-            <a:endParaRPr lang="en-US" sz="930" dirty="0"/>
-          </a:p>
-        </p:txBody>
-      </p:sp>
-      <p:sp>
-        <p:nvSpPr>
-          <p:cNvPr id="18" name="Shape 16"/>
-          <p:cNvSpPr/>
-          <p:nvPr/>
-        </p:nvSpPr>
-        <p:spPr>
-          <a:xfrm>
-            <a:off x="4142232" y="2816352"/>
-            <a:ext cx="146304" cy="0"/>
-          </a:xfrm>
-          <a:prstGeom prst="line">
-            <a:avLst/>
-          </a:prstGeom>
-          <a:noFill/>
-          <a:ln w="12700">
-            <a:solidFill>
-              <a:srgbClr val="13A6A6"/>
-            </a:solidFill>
-            <a:prstDash val="solid"/>
-            <a:headEnd type="none"/>
-            <a:tailEnd type="none"/>
-          </a:ln>
-        </p:spPr>
-        <p:txBody>
-          <a:bodyPr/>
-          <a:p/>
-        </p:txBody>
-      </p:sp>
-      <p:sp>
-        <p:nvSpPr>
-          <p:cNvPr id="19" name="Shape 17"/>
-          <p:cNvSpPr/>
-          <p:nvPr/>
-        </p:nvSpPr>
-        <p:spPr>
-          <a:xfrm>
-            <a:off x="4215384" y="2734056"/>
-            <a:ext cx="137160" cy="164592"/>
-          </a:xfrm>
-          <a:prstGeom prst="chevron">
-            <a:avLst/>
-          </a:prstGeom>
-          <a:solidFill>
-            <a:srgbClr val="13A6A6"/>
-          </a:solidFill>
-          <a:ln w="12700">
-            <a:solidFill>
-              <a:srgbClr val="13A6A6"/>
-            </a:solidFill>
-            <a:prstDash val="solid"/>
-          </a:ln>
-        </p:spPr>
-        <p:txBody>
-          <a:bodyPr/>
-          <a:p/>
-        </p:txBody>
-      </p:sp>
-      <p:sp>
-        <p:nvSpPr>
-          <p:cNvPr id="20" name="Shape 18"/>
-          <p:cNvSpPr/>
-          <p:nvPr/>
-        </p:nvSpPr>
-        <p:spPr>
-          <a:xfrm>
-            <a:off x="4279392" y="2139696"/>
-            <a:ext cx="1737360" cy="1371600"/>
-          </a:xfrm>
-          <a:prstGeom prst="roundRect">
-            <a:avLst>
-              <a:gd name="adj" fmla="val 10667"/>
-            </a:avLst>
-          </a:prstGeom>
-          <a:solidFill>
-            <a:srgbClr val="FFFFFF"/>
-          </a:solidFill>
-          <a:ln w="12700">
-            <a:solidFill>
-              <a:srgbClr val="D8DEE8"/>
-            </a:solidFill>
-            <a:prstDash val="solid"/>
-          </a:ln>
-        </p:spPr>
-        <p:txBody>
-          <a:bodyPr/>
-          <a:p/>
-        </p:txBody>
-      </p:sp>
-      <p:sp>
-        <p:nvSpPr>
-          <p:cNvPr id="21" name="Shape 19"/>
-          <p:cNvSpPr/>
-          <p:nvPr/>
-        </p:nvSpPr>
-        <p:spPr>
-          <a:xfrm>
-            <a:off x="4425696" y="2313432"/>
-            <a:ext cx="384048" cy="310896"/>
-          </a:xfrm>
-          <a:prstGeom prst="roundRect">
-            <a:avLst>
-              <a:gd name="adj" fmla="val 50000"/>
-            </a:avLst>
-          </a:prstGeom>
-          <a:solidFill>
-            <a:srgbClr val="0B1F3A"/>
-          </a:solidFill>
-          <a:ln w="12700">
-            <a:solidFill>
-              <a:srgbClr val="0B1F3A"/>
-            </a:solidFill>
-            <a:prstDash val="solid"/>
-          </a:ln>
-        </p:spPr>
-        <p:txBody>
-          <a:bodyPr/>
-          <a:p/>
-        </p:txBody>
-      </p:sp>
-      <p:sp>
-        <p:nvSpPr>
-          <p:cNvPr id="22" name="Text 20"/>
-          <p:cNvSpPr/>
-          <p:nvPr/>
-        </p:nvSpPr>
-        <p:spPr>
-          <a:xfrm>
-            <a:off x="4498848" y="2331720"/>
-            <a:ext cx="237744" cy="228600"/>
-          </a:xfrm>
-          <a:prstGeom prst="rect">
-            <a:avLst/>
-          </a:prstGeom>
-          <a:noFill/>
-          <a:ln/>
-        </p:spPr>
-        <p:txBody>
-          <a:bodyPr wrap="square" lIns="0" tIns="0" rIns="0" bIns="0" rtlCol="0" anchor="ctr">
-            <a:normAutofit/>
-          </a:bodyPr>
-          <a:lstStyle/>
-          <a:p>
-            <a:pPr algn="ctr" indent="0" marL="0">
-              <a:buNone/>
-            </a:pPr>
-            <a:r>
-              <a:rPr lang="en-US" sz="950" b="1" dirty="0">
-                <a:solidFill>
-                  <a:srgbClr val="FFFFFF"/>
-                </a:solidFill>
-                <a:latin typeface="Aptos" pitchFamily="34" charset="0"/>
-                <a:ea typeface="Aptos" pitchFamily="34" charset="-122"/>
-                <a:cs typeface="Aptos" pitchFamily="34" charset="-120"/>
-              </a:rPr>
-              <a:t>03</a:t>
-            </a:r>
-            <a:endParaRPr lang="en-US" sz="950" dirty="0"/>
-          </a:p>
-        </p:txBody>
-      </p:sp>
-      <p:sp>
-        <p:nvSpPr>
-          <p:cNvPr id="23" name="Text 21"/>
-          <p:cNvSpPr/>
-          <p:nvPr/>
-        </p:nvSpPr>
-        <p:spPr>
-          <a:xfrm>
-            <a:off x="4425696" y="2743200"/>
-            <a:ext cx="1444752" cy="219456"/>
-          </a:xfrm>
-          <a:prstGeom prst="rect">
-            <a:avLst/>
-          </a:prstGeom>
-          <a:noFill/>
-          <a:ln/>
-        </p:spPr>
-        <p:txBody>
-          <a:bodyPr wrap="square" lIns="0" tIns="0" rIns="0" bIns="0" rtlCol="0" anchor="ctr">
-            <a:normAutofit/>
-          </a:bodyPr>
-          <a:lstStyle/>
-          <a:p>
-            <a:pPr algn="ctr" indent="0" marL="0">
-              <a:buNone/>
-            </a:pPr>
-            <a:r>
-              <a:rPr sz="1250" b="1">
-                <a:solidFill>
-                  <a:srgbClr val="0B1F3A"/>
+              <a:t>• Dead Reckoning: Linear extrapolation d_pred = d - v*Δt bridges packet dropouts without false braking.</a:t>
+            </a:r>
+          </a:p>
+          <a:p>
+            <a:pPr algn="l"/>
+            <a:r>
+              <a:rPr sz="950" b="0">
+                <a:solidFill>
+                  <a:srgbClr val="DC2626"/>
                 </a:solidFill>
                 <a:latin typeface="Arial"/>
               </a:rPr>
-              <a:t>Virtual Sequencing</a:t>
-            </a:r>
-            <a:endParaRPr lang="en-US" sz="1250" dirty="0"/>
-          </a:p>
-        </p:txBody>
-      </p:sp>
-      <p:sp>
-        <p:nvSpPr>
-          <p:cNvPr id="24" name="Text 22"/>
-          <p:cNvSpPr/>
-          <p:nvPr/>
-        </p:nvSpPr>
-        <p:spPr>
-          <a:xfrm>
-            <a:off x="4425696" y="3081528"/>
-            <a:ext cx="1444752" cy="274320"/>
-          </a:xfrm>
-          <a:prstGeom prst="rect">
-            <a:avLst/>
-          </a:prstGeom>
-          <a:noFill/>
-          <a:ln/>
-        </p:spPr>
-        <p:txBody>
-          <a:bodyPr wrap="square" lIns="0" tIns="0" rIns="0" bIns="0" rtlCol="0" anchor="ctr">
-            <a:normAutofit/>
-          </a:bodyPr>
-          <a:lstStyle/>
-          <a:p>
-            <a:pPr algn="ctr" indent="0" marL="0">
-              <a:buNone/>
-            </a:pPr>
-            <a:r>
-              <a:rPr sz="930">
-                <a:solidFill>
-                  <a:srgbClr val="5D6B7E"/>
-                </a:solidFill>
-                <a:latin typeface="Arial"/>
-              </a:rPr>
-              <a:t>RSU calculates ETA, assigns FIFO + 1.5s slot</a:t>
-            </a:r>
-            <a:endParaRPr lang="en-US" sz="930" dirty="0"/>
-          </a:p>
-        </p:txBody>
-      </p:sp>
-      <p:sp>
-        <p:nvSpPr>
-          <p:cNvPr id="25" name="Shape 23"/>
-          <p:cNvSpPr/>
-          <p:nvPr/>
-        </p:nvSpPr>
-        <p:spPr>
-          <a:xfrm>
-            <a:off x="6016752" y="2816352"/>
-            <a:ext cx="146304" cy="0"/>
-          </a:xfrm>
-          <a:prstGeom prst="line">
-            <a:avLst/>
-          </a:prstGeom>
-          <a:noFill/>
-          <a:ln w="12700">
-            <a:solidFill>
-              <a:srgbClr val="13A6A6"/>
-            </a:solidFill>
-            <a:prstDash val="solid"/>
-            <a:headEnd type="none"/>
-            <a:tailEnd type="none"/>
-          </a:ln>
-        </p:spPr>
-        <p:txBody>
-          <a:bodyPr/>
-          <a:p/>
-        </p:txBody>
-      </p:sp>
-      <p:sp>
-        <p:nvSpPr>
-          <p:cNvPr id="26" name="Shape 24"/>
-          <p:cNvSpPr/>
-          <p:nvPr/>
-        </p:nvSpPr>
-        <p:spPr>
-          <a:xfrm>
-            <a:off x="6089904" y="2734056"/>
-            <a:ext cx="137160" cy="164592"/>
-          </a:xfrm>
-          <a:prstGeom prst="chevron">
-            <a:avLst/>
-          </a:prstGeom>
-          <a:solidFill>
-            <a:srgbClr val="13A6A6"/>
-          </a:solidFill>
-          <a:ln w="12700">
-            <a:solidFill>
-              <a:srgbClr val="13A6A6"/>
-            </a:solidFill>
-            <a:prstDash val="solid"/>
-          </a:ln>
-        </p:spPr>
-        <p:txBody>
-          <a:bodyPr/>
-          <a:p/>
-        </p:txBody>
-      </p:sp>
-      <p:sp>
-        <p:nvSpPr>
-          <p:cNvPr id="27" name="Shape 25"/>
-          <p:cNvSpPr/>
-          <p:nvPr/>
-        </p:nvSpPr>
-        <p:spPr>
-          <a:xfrm>
-            <a:off x="6153912" y="2139696"/>
-            <a:ext cx="1737360" cy="1371600"/>
-          </a:xfrm>
-          <a:prstGeom prst="roundRect">
-            <a:avLst>
-              <a:gd name="adj" fmla="val 10667"/>
-            </a:avLst>
-          </a:prstGeom>
-          <a:solidFill>
-            <a:srgbClr val="FFFFFF"/>
-          </a:solidFill>
-          <a:ln w="12700">
-            <a:solidFill>
-              <a:srgbClr val="D8DEE8"/>
-            </a:solidFill>
-            <a:prstDash val="solid"/>
-          </a:ln>
-        </p:spPr>
-        <p:txBody>
-          <a:bodyPr/>
-          <a:p/>
-        </p:txBody>
-      </p:sp>
-      <p:sp>
-        <p:nvSpPr>
-          <p:cNvPr id="28" name="Shape 26"/>
-          <p:cNvSpPr/>
-          <p:nvPr/>
-        </p:nvSpPr>
-        <p:spPr>
-          <a:xfrm>
-            <a:off x="6300216" y="2313432"/>
-            <a:ext cx="384048" cy="310896"/>
-          </a:xfrm>
-          <a:prstGeom prst="roundRect">
-            <a:avLst>
-              <a:gd name="adj" fmla="val 50000"/>
-            </a:avLst>
-          </a:prstGeom>
-          <a:solidFill>
-            <a:srgbClr val="E46F5F"/>
-          </a:solidFill>
-          <a:ln w="12700">
-            <a:solidFill>
-              <a:srgbClr val="E46F5F"/>
-            </a:solidFill>
-            <a:prstDash val="solid"/>
-          </a:ln>
-        </p:spPr>
-        <p:txBody>
-          <a:bodyPr/>
-          <a:p/>
-        </p:txBody>
-      </p:sp>
-      <p:sp>
-        <p:nvSpPr>
-          <p:cNvPr id="29" name="Text 27"/>
-          <p:cNvSpPr/>
-          <p:nvPr/>
-        </p:nvSpPr>
-        <p:spPr>
-          <a:xfrm>
-            <a:off x="6373368" y="2331720"/>
-            <a:ext cx="237744" cy="228600"/>
-          </a:xfrm>
-          <a:prstGeom prst="rect">
-            <a:avLst/>
-          </a:prstGeom>
-          <a:noFill/>
-          <a:ln/>
-        </p:spPr>
-        <p:txBody>
-          <a:bodyPr wrap="square" lIns="0" tIns="0" rIns="0" bIns="0" rtlCol="0" anchor="ctr">
-            <a:normAutofit/>
-          </a:bodyPr>
-          <a:lstStyle/>
-          <a:p>
-            <a:pPr algn="ctr" indent="0" marL="0">
-              <a:buNone/>
-            </a:pPr>
-            <a:r>
-              <a:rPr lang="en-US" sz="950" b="1" dirty="0">
-                <a:solidFill>
-                  <a:srgbClr val="FFFFFF"/>
-                </a:solidFill>
-                <a:latin typeface="Aptos" pitchFamily="34" charset="0"/>
-                <a:ea typeface="Aptos" pitchFamily="34" charset="-122"/>
-                <a:cs typeface="Aptos" pitchFamily="34" charset="-120"/>
-              </a:rPr>
-              <a:t>04</a:t>
-            </a:r>
-            <a:endParaRPr lang="en-US" sz="950" dirty="0"/>
-          </a:p>
-        </p:txBody>
-      </p:sp>
-      <p:sp>
-        <p:nvSpPr>
-          <p:cNvPr id="30" name="Text 28"/>
-          <p:cNvSpPr/>
-          <p:nvPr/>
-        </p:nvSpPr>
-        <p:spPr>
-          <a:xfrm>
-            <a:off x="6300216" y="2743200"/>
-            <a:ext cx="1444752" cy="219456"/>
-          </a:xfrm>
-          <a:prstGeom prst="rect">
-            <a:avLst/>
-          </a:prstGeom>
-          <a:noFill/>
-          <a:ln/>
-        </p:spPr>
-        <p:txBody>
-          <a:bodyPr wrap="square" lIns="0" tIns="0" rIns="0" bIns="0" rtlCol="0" anchor="ctr">
-            <a:normAutofit/>
-          </a:bodyPr>
-          <a:lstStyle/>
-          <a:p>
-            <a:pPr algn="ctr" indent="0" marL="0">
-              <a:buNone/>
-            </a:pPr>
-            <a:r>
-              <a:rPr sz="1250" b="1">
-                <a:solidFill>
-                  <a:srgbClr val="0B1F3A"/>
-                </a:solidFill>
-                <a:latin typeface="Arial"/>
-              </a:rPr>
-              <a:t>Distributed CACC</a:t>
-            </a:r>
-            <a:endParaRPr lang="en-US" sz="1250" dirty="0"/>
-          </a:p>
-        </p:txBody>
-      </p:sp>
-      <p:sp>
-        <p:nvSpPr>
-          <p:cNvPr id="31" name="Text 29"/>
-          <p:cNvSpPr/>
-          <p:nvPr/>
-        </p:nvSpPr>
-        <p:spPr>
-          <a:xfrm>
-            <a:off x="6300216" y="3081528"/>
-            <a:ext cx="1444752" cy="274320"/>
-          </a:xfrm>
-          <a:prstGeom prst="rect">
-            <a:avLst/>
-          </a:prstGeom>
-          <a:noFill/>
-          <a:ln/>
-        </p:spPr>
-        <p:txBody>
-          <a:bodyPr wrap="square" lIns="0" tIns="0" rIns="0" bIns="0" rtlCol="0" anchor="ctr">
-            <a:normAutofit/>
-          </a:bodyPr>
-          <a:lstStyle/>
-          <a:p>
-            <a:pPr algn="ctr" indent="0" marL="0">
-              <a:buNone/>
-            </a:pPr>
-            <a:r>
-              <a:rPr sz="930">
-                <a:solidFill>
-                  <a:srgbClr val="5D6B7E"/>
-                </a:solidFill>
-                <a:latin typeface="Arial"/>
-              </a:rPr>
-              <a:t>Vehicles execute consensus control along virtual axis</a:t>
-            </a:r>
-            <a:endParaRPr lang="en-US" sz="930" dirty="0"/>
-          </a:p>
-        </p:txBody>
-      </p:sp>
-      <p:sp>
-        <p:nvSpPr>
-          <p:cNvPr id="32" name="Shape 30"/>
-          <p:cNvSpPr/>
-          <p:nvPr/>
-        </p:nvSpPr>
-        <p:spPr>
-          <a:xfrm>
-            <a:off x="7891272" y="2816352"/>
-            <a:ext cx="146304" cy="0"/>
-          </a:xfrm>
-          <a:prstGeom prst="line">
-            <a:avLst/>
-          </a:prstGeom>
-          <a:noFill/>
-          <a:ln w="12700">
-            <a:solidFill>
-              <a:srgbClr val="13A6A6"/>
-            </a:solidFill>
-            <a:prstDash val="solid"/>
-            <a:headEnd type="none"/>
-            <a:tailEnd type="none"/>
-          </a:ln>
-        </p:spPr>
-        <p:txBody>
-          <a:bodyPr/>
-          <a:p/>
-        </p:txBody>
-      </p:sp>
-      <p:sp>
-        <p:nvSpPr>
-          <p:cNvPr id="33" name="Shape 31"/>
-          <p:cNvSpPr/>
-          <p:nvPr/>
-        </p:nvSpPr>
-        <p:spPr>
-          <a:xfrm>
-            <a:off x="7964424" y="2734056"/>
-            <a:ext cx="137160" cy="164592"/>
-          </a:xfrm>
-          <a:prstGeom prst="chevron">
-            <a:avLst/>
-          </a:prstGeom>
-          <a:solidFill>
-            <a:srgbClr val="13A6A6"/>
-          </a:solidFill>
-          <a:ln w="12700">
-            <a:solidFill>
-              <a:srgbClr val="13A6A6"/>
-            </a:solidFill>
-            <a:prstDash val="solid"/>
-          </a:ln>
-        </p:spPr>
-        <p:txBody>
-          <a:bodyPr/>
-          <a:p/>
-        </p:txBody>
-      </p:sp>
-      <p:sp>
-        <p:nvSpPr>
-          <p:cNvPr id="34" name="Shape 32"/>
-          <p:cNvSpPr/>
-          <p:nvPr/>
-        </p:nvSpPr>
-        <p:spPr>
-          <a:xfrm>
-            <a:off x="8028432" y="2139696"/>
-            <a:ext cx="1737360" cy="1371600"/>
-          </a:xfrm>
-          <a:prstGeom prst="roundRect">
-            <a:avLst>
-              <a:gd name="adj" fmla="val 10667"/>
-            </a:avLst>
-          </a:prstGeom>
-          <a:solidFill>
-            <a:srgbClr val="FFFFFF"/>
-          </a:solidFill>
-          <a:ln w="12700">
-            <a:solidFill>
-              <a:srgbClr val="D8DEE8"/>
-            </a:solidFill>
-            <a:prstDash val="solid"/>
-          </a:ln>
-        </p:spPr>
-        <p:txBody>
-          <a:bodyPr/>
-          <a:p/>
-        </p:txBody>
-      </p:sp>
-      <p:sp>
-        <p:nvSpPr>
-          <p:cNvPr id="35" name="Shape 33"/>
-          <p:cNvSpPr/>
-          <p:nvPr/>
-        </p:nvSpPr>
-        <p:spPr>
-          <a:xfrm>
-            <a:off x="8174736" y="2313432"/>
-            <a:ext cx="384048" cy="310896"/>
-          </a:xfrm>
-          <a:prstGeom prst="roundRect">
-            <a:avLst>
-              <a:gd name="adj" fmla="val 50000"/>
-            </a:avLst>
-          </a:prstGeom>
-          <a:solidFill>
-            <a:srgbClr val="0B1F3A"/>
-          </a:solidFill>
-          <a:ln w="12700">
-            <a:solidFill>
-              <a:srgbClr val="0B1F3A"/>
-            </a:solidFill>
-            <a:prstDash val="solid"/>
-          </a:ln>
-        </p:spPr>
-        <p:txBody>
-          <a:bodyPr/>
-          <a:p/>
-        </p:txBody>
-      </p:sp>
-      <p:sp>
-        <p:nvSpPr>
-          <p:cNvPr id="36" name="Text 34"/>
-          <p:cNvSpPr/>
-          <p:nvPr/>
-        </p:nvSpPr>
-        <p:spPr>
-          <a:xfrm>
-            <a:off x="8247888" y="2331720"/>
-            <a:ext cx="237744" cy="228600"/>
-          </a:xfrm>
-          <a:prstGeom prst="rect">
-            <a:avLst/>
-          </a:prstGeom>
-          <a:noFill/>
-          <a:ln/>
-        </p:spPr>
-        <p:txBody>
-          <a:bodyPr wrap="square" lIns="0" tIns="0" rIns="0" bIns="0" rtlCol="0" anchor="ctr">
-            <a:normAutofit/>
-          </a:bodyPr>
-          <a:lstStyle/>
-          <a:p>
-            <a:pPr algn="ctr" indent="0" marL="0">
-              <a:buNone/>
-            </a:pPr>
-            <a:r>
-              <a:rPr lang="en-US" sz="950" b="1" dirty="0">
-                <a:solidFill>
-                  <a:srgbClr val="FFFFFF"/>
-                </a:solidFill>
-                <a:latin typeface="Aptos" pitchFamily="34" charset="0"/>
-                <a:ea typeface="Aptos" pitchFamily="34" charset="-122"/>
-                <a:cs typeface="Aptos" pitchFamily="34" charset="-120"/>
-              </a:rPr>
-              <a:t>05</a:t>
-            </a:r>
-            <a:endParaRPr lang="en-US" sz="950" dirty="0"/>
-          </a:p>
-        </p:txBody>
-      </p:sp>
-      <p:sp>
-        <p:nvSpPr>
-          <p:cNvPr id="37" name="Text 35"/>
-          <p:cNvSpPr/>
-          <p:nvPr/>
-        </p:nvSpPr>
-        <p:spPr>
-          <a:xfrm>
-            <a:off x="8174736" y="2743200"/>
-            <a:ext cx="1444752" cy="219456"/>
-          </a:xfrm>
-          <a:prstGeom prst="rect">
-            <a:avLst/>
-          </a:prstGeom>
-          <a:noFill/>
-          <a:ln/>
-        </p:spPr>
-        <p:txBody>
-          <a:bodyPr wrap="square" lIns="0" tIns="0" rIns="0" bIns="0" rtlCol="0" anchor="ctr">
-            <a:normAutofit/>
-          </a:bodyPr>
-          <a:lstStyle/>
-          <a:p>
-            <a:pPr algn="ctr" indent="0" marL="0">
-              <a:buNone/>
-            </a:pPr>
-            <a:r>
-              <a:rPr sz="1250" b="1">
-                <a:solidFill>
-                  <a:srgbClr val="0B1F3A"/>
-                </a:solidFill>
-                <a:latin typeface="Arial"/>
-              </a:rPr>
-              <a:t>Event Trigger V2V</a:t>
-            </a:r>
-            <a:endParaRPr lang="en-US" sz="1250" dirty="0"/>
-          </a:p>
-        </p:txBody>
-      </p:sp>
-      <p:sp>
-        <p:nvSpPr>
-          <p:cNvPr id="38" name="Text 36"/>
-          <p:cNvSpPr/>
-          <p:nvPr/>
-        </p:nvSpPr>
-        <p:spPr>
-          <a:xfrm>
-            <a:off x="8174736" y="3081528"/>
-            <a:ext cx="1444752" cy="274320"/>
-          </a:xfrm>
-          <a:prstGeom prst="rect">
-            <a:avLst/>
-          </a:prstGeom>
-          <a:noFill/>
-          <a:ln/>
-        </p:spPr>
-        <p:txBody>
-          <a:bodyPr wrap="square" lIns="0" tIns="0" rIns="0" bIns="0" rtlCol="0" anchor="ctr">
-            <a:normAutofit/>
-          </a:bodyPr>
-          <a:lstStyle/>
-          <a:p>
-            <a:pPr algn="ctr" indent="0" marL="0">
-              <a:buNone/>
-            </a:pPr>
-            <a:r>
-              <a:rPr sz="930">
-                <a:solidFill>
-                  <a:srgbClr val="5D6B7E"/>
-                </a:solidFill>
-                <a:latin typeface="Arial"/>
-              </a:rPr>
-              <a:t>Broadcast on Δv ≥ 0.3 m/s, Δd ≥ 0.5 m, or 1.0s heartbeat</a:t>
-            </a:r>
-            <a:endParaRPr lang="en-US" sz="930" dirty="0"/>
-          </a:p>
-        </p:txBody>
-      </p:sp>
-      <p:sp>
-        <p:nvSpPr>
-          <p:cNvPr id="39" name="Shape 37"/>
-          <p:cNvSpPr/>
-          <p:nvPr/>
-        </p:nvSpPr>
-        <p:spPr>
-          <a:xfrm>
-            <a:off x="9765792" y="2816352"/>
-            <a:ext cx="146304" cy="0"/>
-          </a:xfrm>
-          <a:prstGeom prst="line">
-            <a:avLst/>
-          </a:prstGeom>
-          <a:noFill/>
-          <a:ln w="12700">
-            <a:solidFill>
-              <a:srgbClr val="13A6A6"/>
-            </a:solidFill>
-            <a:prstDash val="solid"/>
-            <a:headEnd type="none"/>
-            <a:tailEnd type="none"/>
-          </a:ln>
-        </p:spPr>
-        <p:txBody>
-          <a:bodyPr/>
-          <a:p/>
-        </p:txBody>
-      </p:sp>
-      <p:sp>
-        <p:nvSpPr>
-          <p:cNvPr id="40" name="Shape 38"/>
-          <p:cNvSpPr/>
-          <p:nvPr/>
-        </p:nvSpPr>
-        <p:spPr>
-          <a:xfrm>
-            <a:off x="9838944" y="2734056"/>
-            <a:ext cx="137160" cy="164592"/>
-          </a:xfrm>
-          <a:prstGeom prst="chevron">
-            <a:avLst/>
-          </a:prstGeom>
-          <a:solidFill>
-            <a:srgbClr val="13A6A6"/>
-          </a:solidFill>
-          <a:ln w="12700">
-            <a:solidFill>
-              <a:srgbClr val="13A6A6"/>
-            </a:solidFill>
-            <a:prstDash val="solid"/>
-          </a:ln>
-        </p:spPr>
-        <p:txBody>
-          <a:bodyPr/>
-          <a:p/>
-        </p:txBody>
-      </p:sp>
-      <p:sp>
-        <p:nvSpPr>
-          <p:cNvPr id="41" name="Shape 39"/>
-          <p:cNvSpPr/>
-          <p:nvPr/>
-        </p:nvSpPr>
-        <p:spPr>
-          <a:xfrm>
-            <a:off x="9902952" y="2139696"/>
-            <a:ext cx="1737360" cy="1371600"/>
-          </a:xfrm>
-          <a:prstGeom prst="roundRect">
-            <a:avLst>
-              <a:gd name="adj" fmla="val 10667"/>
-            </a:avLst>
-          </a:prstGeom>
-          <a:solidFill>
-            <a:srgbClr val="FFFFFF"/>
-          </a:solidFill>
-          <a:ln w="12700">
-            <a:solidFill>
-              <a:srgbClr val="D8DEE8"/>
-            </a:solidFill>
-            <a:prstDash val="solid"/>
-          </a:ln>
-        </p:spPr>
-        <p:txBody>
-          <a:bodyPr/>
-          <a:p/>
-        </p:txBody>
-      </p:sp>
-      <p:sp>
-        <p:nvSpPr>
-          <p:cNvPr id="42" name="Shape 40"/>
-          <p:cNvSpPr/>
-          <p:nvPr/>
-        </p:nvSpPr>
-        <p:spPr>
-          <a:xfrm>
-            <a:off x="10049256" y="2313432"/>
-            <a:ext cx="384048" cy="310896"/>
-          </a:xfrm>
-          <a:prstGeom prst="roundRect">
-            <a:avLst>
-              <a:gd name="adj" fmla="val 50000"/>
-            </a:avLst>
-          </a:prstGeom>
-          <a:solidFill>
-            <a:srgbClr val="13A6A6"/>
-          </a:solidFill>
-          <a:ln w="12700">
-            <a:solidFill>
-              <a:srgbClr val="13A6A6"/>
-            </a:solidFill>
-            <a:prstDash val="solid"/>
-          </a:ln>
-        </p:spPr>
-        <p:txBody>
-          <a:bodyPr/>
-          <a:p/>
-        </p:txBody>
-      </p:sp>
-      <p:sp>
-        <p:nvSpPr>
-          <p:cNvPr id="43" name="Text 41"/>
-          <p:cNvSpPr/>
-          <p:nvPr/>
-        </p:nvSpPr>
-        <p:spPr>
-          <a:xfrm>
-            <a:off x="10122408" y="2331720"/>
-            <a:ext cx="237744" cy="228600"/>
-          </a:xfrm>
-          <a:prstGeom prst="rect">
-            <a:avLst/>
-          </a:prstGeom>
-          <a:noFill/>
-          <a:ln/>
-        </p:spPr>
-        <p:txBody>
-          <a:bodyPr wrap="square" lIns="0" tIns="0" rIns="0" bIns="0" rtlCol="0" anchor="ctr">
-            <a:normAutofit/>
-          </a:bodyPr>
-          <a:lstStyle/>
-          <a:p>
-            <a:pPr algn="ctr" indent="0" marL="0">
-              <a:buNone/>
-            </a:pPr>
-            <a:r>
-              <a:rPr lang="en-US" sz="950" b="1" dirty="0">
-                <a:solidFill>
-                  <a:srgbClr val="FFFFFF"/>
-                </a:solidFill>
-                <a:latin typeface="Aptos" pitchFamily="34" charset="0"/>
-                <a:ea typeface="Aptos" pitchFamily="34" charset="-122"/>
-                <a:cs typeface="Aptos" pitchFamily="34" charset="-120"/>
-              </a:rPr>
-              <a:t>06</a:t>
-            </a:r>
-            <a:endParaRPr lang="en-US" sz="950" dirty="0"/>
-          </a:p>
-        </p:txBody>
-      </p:sp>
-      <p:sp>
-        <p:nvSpPr>
-          <p:cNvPr id="44" name="Text 42"/>
-          <p:cNvSpPr/>
-          <p:nvPr/>
-        </p:nvSpPr>
-        <p:spPr>
-          <a:xfrm>
-            <a:off x="10049256" y="2743200"/>
-            <a:ext cx="1444752" cy="219456"/>
-          </a:xfrm>
-          <a:prstGeom prst="rect">
-            <a:avLst/>
-          </a:prstGeom>
-          <a:noFill/>
-          <a:ln/>
-        </p:spPr>
-        <p:txBody>
-          <a:bodyPr wrap="square" lIns="0" tIns="0" rIns="0" bIns="0" rtlCol="0" anchor="ctr">
-            <a:normAutofit/>
-          </a:bodyPr>
-          <a:lstStyle/>
-          <a:p>
-            <a:pPr algn="ctr" indent="0" marL="0">
-              <a:buNone/>
-            </a:pPr>
-            <a:r>
-              <a:rPr sz="1250" b="1">
-                <a:solidFill>
-                  <a:srgbClr val="0B1F3A"/>
-                </a:solidFill>
-                <a:latin typeface="Arial"/>
-              </a:rPr>
-              <a:t>Autonomous Safety</a:t>
-            </a:r>
-            <a:endParaRPr lang="en-US" sz="1250" dirty="0"/>
-          </a:p>
-        </p:txBody>
-      </p:sp>
-      <p:sp>
-        <p:nvSpPr>
-          <p:cNvPr id="45" name="Text 43"/>
-          <p:cNvSpPr/>
-          <p:nvPr/>
-        </p:nvSpPr>
-        <p:spPr>
-          <a:xfrm>
-            <a:off x="10049256" y="3081528"/>
-            <a:ext cx="1444752" cy="274320"/>
-          </a:xfrm>
-          <a:prstGeom prst="rect">
-            <a:avLst/>
-          </a:prstGeom>
-          <a:noFill/>
-          <a:ln/>
-        </p:spPr>
-        <p:txBody>
-          <a:bodyPr wrap="square" lIns="0" tIns="0" rIns="0" bIns="0" rtlCol="0" anchor="ctr">
-            <a:normAutofit/>
-          </a:bodyPr>
-          <a:lstStyle/>
-          <a:p>
-            <a:pPr algn="ctr" indent="0" marL="0">
-              <a:buNone/>
-            </a:pPr>
-            <a:r>
-              <a:rPr sz="930">
-                <a:solidFill>
-                  <a:srgbClr val="5D6B7E"/>
-                </a:solidFill>
-                <a:latin typeface="Arial"/>
-              </a:rPr>
-              <a:t>Radar fail-safe engages SUMO car-following if TTC &lt; 2.0s</a:t>
-            </a:r>
-            <a:endParaRPr lang="en-US" sz="930" dirty="0"/>
-          </a:p>
-        </p:txBody>
-      </p:sp>
-      <p:sp>
-        <p:nvSpPr>
-          <p:cNvPr id="46" name="Shape 44"/>
-          <p:cNvSpPr/>
-          <p:nvPr/>
-        </p:nvSpPr>
-        <p:spPr>
-          <a:xfrm>
-            <a:off x="658368" y="4041648"/>
-            <a:ext cx="6583680" cy="1417320"/>
-          </a:xfrm>
-          <a:prstGeom prst="roundRect">
-            <a:avLst>
-              <a:gd name="adj" fmla="val 10323"/>
-            </a:avLst>
-          </a:prstGeom>
-          <a:solidFill>
-            <a:srgbClr val="0B1F3A"/>
-          </a:solidFill>
-          <a:ln w="12700">
-            <a:solidFill>
-              <a:srgbClr val="0B1F3A"/>
-            </a:solidFill>
-            <a:prstDash val="solid"/>
-          </a:ln>
-        </p:spPr>
-        <p:txBody>
-          <a:bodyPr/>
-          <a:p/>
-        </p:txBody>
-      </p:sp>
-      <p:sp>
-        <p:nvSpPr>
-          <p:cNvPr id="47" name="Text 45"/>
-          <p:cNvSpPr/>
-          <p:nvPr/>
-        </p:nvSpPr>
-        <p:spPr>
-          <a:xfrm>
-            <a:off x="896112" y="4315968"/>
-            <a:ext cx="1234440" cy="201168"/>
-          </a:xfrm>
-          <a:prstGeom prst="rect">
-            <a:avLst/>
-          </a:prstGeom>
-          <a:noFill/>
-          <a:ln/>
-        </p:spPr>
-        <p:txBody>
-          <a:bodyPr wrap="square" lIns="0" tIns="0" rIns="0" bIns="0" rtlCol="0" anchor="ctr">
-            <a:normAutofit/>
-          </a:bodyPr>
-          <a:lstStyle/>
-          <a:p>
-            <a:pPr algn="l" indent="0" marL="0">
-              <a:buNone/>
-            </a:pPr>
-            <a:r>
-              <a:rPr sz="1000" b="1">
-                <a:solidFill>
-                  <a:srgbClr val="9FC0DB"/>
-                </a:solidFill>
-                <a:latin typeface="Arial"/>
-              </a:rPr>
-              <a:t>Hierarchical Control Strategy</a:t>
-            </a:r>
-            <a:endParaRPr lang="en-US" sz="1000" dirty="0"/>
-          </a:p>
-        </p:txBody>
-      </p:sp>
-      <p:sp>
-        <p:nvSpPr>
-          <p:cNvPr id="48" name="Text 46"/>
-          <p:cNvSpPr/>
-          <p:nvPr/>
-        </p:nvSpPr>
-        <p:spPr>
-          <a:xfrm>
-            <a:off x="2084832" y="4242816"/>
-            <a:ext cx="4754880" cy="365760"/>
-          </a:xfrm>
-          <a:prstGeom prst="rect">
-            <a:avLst/>
-          </a:prstGeom>
-          <a:noFill/>
-          <a:ln/>
-        </p:spPr>
-        <p:txBody>
-          <a:bodyPr wrap="square" lIns="0" tIns="0" rIns="0" bIns="0" rtlCol="0" anchor="ctr">
-            <a:normAutofit/>
-          </a:bodyPr>
-          <a:lstStyle/>
-          <a:p>
-            <a:pPr algn="l" indent="0" marL="0">
-              <a:buNone/>
-            </a:pPr>
-            <a:r>
-              <a:rPr sz="1700" b="1">
-                <a:solidFill>
-                  <a:srgbClr val="FFFFFF"/>
-                </a:solidFill>
-                <a:latin typeface="Arial"/>
-              </a:rPr>
-              <a:t>Macro-Coordination (0.5 Hz RSU) + Micro-Execution (10 Hz Onboard)</a:t>
-            </a:r>
-            <a:endParaRPr lang="en-US" sz="1700" dirty="0"/>
-          </a:p>
-        </p:txBody>
-      </p:sp>
-      <p:sp>
-        <p:nvSpPr>
-          <p:cNvPr id="49" name="Text 47"/>
-          <p:cNvSpPr/>
-          <p:nvPr/>
-        </p:nvSpPr>
-        <p:spPr>
-          <a:xfrm>
-            <a:off x="2084832" y="4690872"/>
-            <a:ext cx="4617720" cy="411480"/>
-          </a:xfrm>
-          <a:prstGeom prst="rect">
-            <a:avLst/>
-          </a:prstGeom>
-          <a:noFill/>
-          <a:ln/>
-        </p:spPr>
-        <p:txBody>
-          <a:bodyPr wrap="square" lIns="0" tIns="0" rIns="0" bIns="0" rtlCol="0" anchor="ctr">
-            <a:normAutofit/>
-          </a:bodyPr>
-          <a:lstStyle/>
-          <a:p>
-            <a:pPr algn="l" indent="0" marL="0">
-              <a:buNone/>
-            </a:pPr>
-            <a:r>
-              <a:rPr sz="1050">
-                <a:solidFill>
-                  <a:srgbClr val="C6D8E8"/>
-                </a:solidFill>
-                <a:latin typeface="Arial"/>
-              </a:rPr>
-              <a:t>The RSU provides macroscopic collision-free slot allocations at low frequency (0.5 Hz), while CAVs execute high-frequency (10 Hz) longitudinal consensus control locally. The event-triggered filter suppresses 90% of redundant V2V packets during steady-state tracking.</a:t>
-            </a:r>
-            <a:endParaRPr lang="en-US" sz="1050" dirty="0"/>
-          </a:p>
-        </p:txBody>
-      </p:sp>
-      <p:sp>
-        <p:nvSpPr>
-          <p:cNvPr id="50" name="Shape 48"/>
-          <p:cNvSpPr/>
-          <p:nvPr/>
-        </p:nvSpPr>
-        <p:spPr>
-          <a:xfrm>
-            <a:off x="7516368" y="4041648"/>
-            <a:ext cx="3895344" cy="1417320"/>
-          </a:xfrm>
-          <a:prstGeom prst="roundRect">
-            <a:avLst>
-              <a:gd name="adj" fmla="val 10323"/>
-            </a:avLst>
-          </a:prstGeom>
-          <a:solidFill>
-            <a:srgbClr val="FFFFFF"/>
-          </a:solidFill>
-          <a:ln w="12700">
-            <a:solidFill>
-              <a:srgbClr val="D8DEE8"/>
-            </a:solidFill>
-            <a:prstDash val="solid"/>
-          </a:ln>
-        </p:spPr>
-        <p:txBody>
-          <a:bodyPr/>
-          <a:p/>
-        </p:txBody>
-      </p:sp>
-      <p:sp>
-        <p:nvSpPr>
-          <p:cNvPr id="51" name="Text 49"/>
-          <p:cNvSpPr/>
-          <p:nvPr/>
-        </p:nvSpPr>
-        <p:spPr>
-          <a:xfrm>
-            <a:off x="7772400" y="4306824"/>
-            <a:ext cx="2057400" cy="201168"/>
-          </a:xfrm>
-          <a:prstGeom prst="rect">
-            <a:avLst/>
-          </a:prstGeom>
-          <a:noFill/>
-          <a:ln/>
-        </p:spPr>
-        <p:txBody>
-          <a:bodyPr wrap="square" lIns="0" tIns="0" rIns="0" bIns="0" rtlCol="0" anchor="ctr">
-            <a:normAutofit/>
-          </a:bodyPr>
-          <a:lstStyle/>
-          <a:p>
-            <a:pPr algn="l" indent="0" marL="0">
-              <a:buNone/>
-            </a:pPr>
-            <a:r>
-              <a:rPr sz="1000" b="1">
-                <a:solidFill>
-                  <a:srgbClr val="13A6A6"/>
-                </a:solidFill>
-                <a:latin typeface="Arial"/>
-              </a:rPr>
-              <a:t>Consensus Law &amp; Dead Reckoning Protocol</a:t>
-            </a:r>
-            <a:endParaRPr lang="en-US" sz="1000" dirty="0"/>
+              <a:t>• Autonomous Fail-Safe: Onboard radar overrides control if TTC &lt; 2.0 s.</a:t>
+            </a:r>
           </a:p>
         </p:txBody>
       </p:sp>
@@ -20697,21 +19992,7 @@
             <a:normAutofit/>
           </a:bodyPr>
           <a:lstStyle/>
-          <a:p>
-            <a:pPr algn="l" indent="0" marL="0">
-              <a:buNone/>
-            </a:pPr>
-            <a:r>
-              <a:rPr sz="1200" b="1">
-                <a:solidFill>
-                  <a:srgbClr val="0B1F3A"/>
-                </a:solidFill>
-                <a:latin typeface="Arial"/>
-              </a:rPr>
-              <a:t>Acceleration law: a = -kp*(d_des - gap_ghost) - kv*(v - v_pred). Followers apply constant-velocity dead reckoning d_pred(t) = d_last - v_last * Δt during silent intervals, preventing false deceleration.</a:t>
-            </a:r>
-            <a:endParaRPr lang="en-US" sz="1200" dirty="0"/>
-          </a:p>
+          <a:p/>
         </p:txBody>
       </p:sp>
       <p:sp>
@@ -20753,15 +20034,43 @@
             </a:lvl1pPr>
           </a:lstStyle>
           <a:p>
-            <a:pPr algn="l"/>
-            <a:fld id="{F7021451-1387-4CA6-816F-3879F97B5CBC}" type="slidenum">
-              <a:rPr b="0" lang="en-US"/>
+            <a:pPr>
+              <a:defRPr sz="1000">
+                <a:solidFill>
+                  <a:srgbClr val="94A3B8"/>
+                </a:solidFill>
+              </a:defRPr>
+            </a:pPr>
+            <a:r>
               <a:t>9</a:t>
-            </a:fld>
-            <a:endParaRPr lang="en-US"/>
-          </a:p>
-        </p:txBody>
-      </p:sp>
+            </a:r>
+          </a:p>
+        </p:txBody>
+      </p:sp>
+      <p:pic>
+        <p:nvPicPr>
+          <p:cNvPr id="53" name="Picture 52" descr="system_architecture_pipeline.png"/>
+          <p:cNvPicPr>
+            <a:picLocks noChangeAspect="1"/>
+          </p:cNvPicPr>
+          <p:nvPr/>
+        </p:nvPicPr>
+        <p:blipFill>
+          <a:blip r:embed="rId3"/>
+          <a:stretch>
+            <a:fillRect/>
+          </a:stretch>
+        </p:blipFill>
+        <p:spPr>
+          <a:xfrm>
+            <a:off x="530352" y="1783080"/>
+            <a:ext cx="10991088" cy="3077505"/>
+          </a:xfrm>
+          <a:prstGeom prst="rect">
+            <a:avLst/>
+          </a:prstGeom>
+        </p:spPr>
+      </p:pic>
     </p:spTree>
   </p:cSld>
   <p:clrMapOvr>

</xml_diff>